<commit_message>
[design] Rebuild logo presentation with Spotify Wrapped arc aesthetic
Replaced flat layout with concentric arc motif from Spotify Wrapped 2025
Figma templates (nodes 3:406, 2:378, 2:379). Arc stripes generated as
transparent PNGs via sharp and embedded at slide corners. Dark/cream
sandwich structure, Project AIR green palette throughout.
</commit_message>
<xml_diff>
--- a/assets/templates/logo-presentation.pptx
+++ b/assets/templates/logo-presentation.pptx
@@ -1142,16 +1142,64 @@
           <a:chExt cx="0" cy="0"/>
         </a:xfrm>
       </p:grpSpPr>
-      <p:sp>
-        <p:nvSpPr>
-          <p:cNvPr id="2" name="Shape 0"/>
+      <p:pic>
+        <p:nvPicPr>
+          <p:cNvPr id="2" name="Image 0" descr="preencoded.png">    </p:cNvPr>
+          <p:cNvPicPr>
+            <a:picLocks noChangeAspect="1"/>
+          </p:cNvPicPr>
+          <p:nvPr/>
+        </p:nvPicPr>
+        <p:blipFill>
+          <a:blip r:embed="rId1"/>
+          <a:stretch>
+            <a:fillRect/>
+          </a:stretch>
+        </p:blipFill>
+        <p:spPr>
+          <a:xfrm>
+            <a:off x="6446520" y="0"/>
+            <a:ext cx="2697480" cy="2697480"/>
+          </a:xfrm>
+          <a:prstGeom prst="rect">
+            <a:avLst/>
+          </a:prstGeom>
+        </p:spPr>
+      </p:pic>
+      <p:pic>
+        <p:nvPicPr>
+          <p:cNvPr id="3" name="Image 1" descr="preencoded.png">    </p:cNvPr>
+          <p:cNvPicPr>
+            <a:picLocks noChangeAspect="1"/>
+          </p:cNvPicPr>
+          <p:nvPr/>
+        </p:nvPicPr>
+        <p:blipFill>
+          <a:blip r:embed="rId2"/>
+          <a:stretch>
+            <a:fillRect/>
+          </a:stretch>
+        </p:blipFill>
+        <p:spPr>
+          <a:xfrm>
+            <a:off x="0" y="3314700"/>
+            <a:ext cx="1828800" cy="1828800"/>
+          </a:xfrm>
+          <a:prstGeom prst="rect">
+            <a:avLst/>
+          </a:prstGeom>
+        </p:spPr>
+      </p:pic>
+      <p:sp>
+        <p:nvSpPr>
+          <p:cNvPr id="4" name="Shape 0"/>
           <p:cNvSpPr/>
           <p:nvPr/>
         </p:nvSpPr>
         <p:spPr>
           <a:xfrm>
             <a:off x="0" y="0"/>
-            <a:ext cx="292608" cy="5143500"/>
+            <a:ext cx="256032" cy="5143500"/>
           </a:xfrm>
           <a:prstGeom prst="rect">
             <a:avLst/>
@@ -1169,14 +1217,14 @@
       </p:sp>
       <p:sp>
         <p:nvSpPr>
-          <p:cNvPr id="3" name="Text 1"/>
-          <p:cNvSpPr/>
-          <p:nvPr/>
-        </p:nvSpPr>
-        <p:spPr>
-          <a:xfrm>
-            <a:off x="548640" y="1188720"/>
-            <a:ext cx="8229600" cy="1005840"/>
+          <p:cNvPr id="5" name="Text 1"/>
+          <p:cNvSpPr/>
+          <p:nvPr/>
+        </p:nvSpPr>
+        <p:spPr>
+          <a:xfrm>
+            <a:off x="502920" y="1005840"/>
+            <a:ext cx="6583680" cy="1051560"/>
           </a:xfrm>
           <a:prstGeom prst="rect">
             <a:avLst/>
@@ -1192,7 +1240,7 @@
               <a:buNone/>
             </a:pPr>
             <a:r>
-              <a:rPr lang="en-US" sz="4400" b="1" dirty="0">
+              <a:rPr lang="en-US" sz="5600" b="1" spc="300" kern="0" dirty="0">
                 <a:solidFill>
                   <a:srgbClr val="FFFFFF"/>
                 </a:solidFill>
@@ -1200,22 +1248,22 @@
                 <a:ea typeface="Calibri" pitchFamily="34" charset="-122"/>
                 <a:cs typeface="Calibri" pitchFamily="34" charset="-120"/>
               </a:rPr>
-              <a:t>Project AIR — Logo Direction</a:t>
-            </a:r>
-            <a:endParaRPr lang="en-US" sz="4400" dirty="0"/>
-          </a:p>
-        </p:txBody>
-      </p:sp>
-      <p:sp>
-        <p:nvSpPr>
-          <p:cNvPr id="4" name="Text 2"/>
-          <p:cNvSpPr/>
-          <p:nvPr/>
-        </p:nvSpPr>
-        <p:spPr>
-          <a:xfrm>
-            <a:off x="548640" y="2331720"/>
-            <a:ext cx="8229600" cy="384048"/>
+              <a:t>PROJECT AIR</a:t>
+            </a:r>
+            <a:endParaRPr lang="en-US" sz="5600" dirty="0"/>
+          </a:p>
+        </p:txBody>
+      </p:sp>
+      <p:sp>
+        <p:nvSpPr>
+          <p:cNvPr id="6" name="Text 2"/>
+          <p:cNvSpPr/>
+          <p:nvPr/>
+        </p:nvSpPr>
+        <p:spPr>
+          <a:xfrm>
+            <a:off x="502920" y="2148840"/>
+            <a:ext cx="6583680" cy="457200"/>
           </a:xfrm>
           <a:prstGeom prst="rect">
             <a:avLst/>
@@ -1231,7 +1279,7 @@
               <a:buNone/>
             </a:pPr>
             <a:r>
-              <a:rPr lang="en-US" sz="1300" spc="100" kern="0" dirty="0">
+              <a:rPr lang="en-US" sz="2000" spc="500" kern="0" dirty="0">
                 <a:solidFill>
                   <a:srgbClr val="9DC08B"/>
                 </a:solidFill>
@@ -1239,21 +1287,21 @@
                 <a:ea typeface="Calibri" pitchFamily="34" charset="-122"/>
                 <a:cs typeface="Calibri" pitchFamily="34" charset="-120"/>
               </a:rPr>
-              <a:t>AI in Reach  ·  The Weather Company  ·  AI Day, June 9, 2026</a:t>
-            </a:r>
-            <a:endParaRPr lang="en-US" sz="1300" dirty="0"/>
-          </a:p>
-        </p:txBody>
-      </p:sp>
-      <p:sp>
-        <p:nvSpPr>
-          <p:cNvPr id="5" name="Shape 3"/>
-          <p:cNvSpPr/>
-          <p:nvPr/>
-        </p:nvSpPr>
-        <p:spPr>
-          <a:xfrm>
-            <a:off x="548640" y="2852928"/>
+              <a:t>LOGO DIRECTION</a:t>
+            </a:r>
+            <a:endParaRPr lang="en-US" sz="2000" dirty="0"/>
+          </a:p>
+        </p:txBody>
+      </p:sp>
+      <p:sp>
+        <p:nvSpPr>
+          <p:cNvPr id="7" name="Shape 3"/>
+          <p:cNvSpPr/>
+          <p:nvPr/>
+        </p:nvSpPr>
+        <p:spPr>
+          <a:xfrm>
+            <a:off x="502920" y="2743200"/>
             <a:ext cx="2560320" cy="0"/>
           </a:xfrm>
           <a:prstGeom prst="line">
@@ -1270,14 +1318,14 @@
       </p:sp>
       <p:sp>
         <p:nvSpPr>
-          <p:cNvPr id="6" name="Text 4"/>
-          <p:cNvSpPr/>
-          <p:nvPr/>
-        </p:nvSpPr>
-        <p:spPr>
-          <a:xfrm>
-            <a:off x="548640" y="3035808"/>
-            <a:ext cx="8046720" cy="1737360"/>
+          <p:cNvPr id="8" name="Text 4"/>
+          <p:cNvSpPr/>
+          <p:nvPr/>
+        </p:nvSpPr>
+        <p:spPr>
+          <a:xfrm>
+            <a:off x="502920" y="2907792"/>
+            <a:ext cx="6217920" cy="1737360"/>
           </a:xfrm>
           <a:prstGeom prst="rect">
             <a:avLst/>
@@ -1291,12 +1339,12 @@
           <a:p>
             <a:pPr algn="l" indent="0" marL="0">
               <a:lnSpc>
-                <a:spcPct val="135000"/>
+                <a:spcPct val="140000"/>
               </a:lnSpc>
               <a:buNone/>
             </a:pPr>
             <a:r>
-              <a:rPr lang="en-US" sz="1300" dirty="0">
+              <a:rPr lang="en-US" sz="1250" dirty="0">
                 <a:solidFill>
                   <a:srgbClr val="C5D5BB"/>
                 </a:solidFill>
@@ -1304,9 +1352,9 @@
                 <a:ea typeface="Calibri" pitchFamily="34" charset="-122"/>
                 <a:cs typeface="Calibri" pitchFamily="34" charset="-120"/>
               </a:rPr>
-              <a:t>This presentation shows the logo concept(s) for Project AIR: AI in Reach. The logo is the foundation — once it is approved, it unlocks every other deliverable: the poster system, badge and lanyard design, the PowerPoint template, and swag. Feedback here moves the whole project forward.</a:t>
-            </a:r>
-            <a:endParaRPr lang="en-US" sz="1300" dirty="0"/>
+              <a:t>This presentation shows the logo concept(s) for Project AIR: AI in Reach. The logo is the foundation — once approved, it unlocks every other deliverable: the poster system, badge and lanyard design, the PowerPoint template, and swag. Feedback here moves the whole project forward.</a:t>
+            </a:r>
+            <a:endParaRPr lang="en-US" sz="1250" dirty="0"/>
           </a:p>
         </p:txBody>
       </p:sp>
@@ -1342,9 +1390,33 @@
           <a:chExt cx="0" cy="0"/>
         </a:xfrm>
       </p:grpSpPr>
-      <p:sp>
-        <p:nvSpPr>
-          <p:cNvPr id="2" name="Shape 0"/>
+      <p:pic>
+        <p:nvPicPr>
+          <p:cNvPr id="2" name="Image 0" descr="preencoded.png">    </p:cNvPr>
+          <p:cNvPicPr>
+            <a:picLocks noChangeAspect="1"/>
+          </p:cNvPicPr>
+          <p:nvPr/>
+        </p:nvPicPr>
+        <p:blipFill>
+          <a:blip r:embed="rId1"/>
+          <a:stretch>
+            <a:fillRect/>
+          </a:stretch>
+        </p:blipFill>
+        <p:spPr>
+          <a:xfrm>
+            <a:off x="6903720" y="0"/>
+            <a:ext cx="2240280" cy="2240280"/>
+          </a:xfrm>
+          <a:prstGeom prst="rect">
+            <a:avLst/>
+          </a:prstGeom>
+        </p:spPr>
+      </p:pic>
+      <p:sp>
+        <p:nvSpPr>
+          <p:cNvPr id="3" name="Shape 0"/>
           <p:cNvSpPr/>
           <p:nvPr/>
         </p:nvSpPr>
@@ -1369,14 +1441,14 @@
       </p:sp>
       <p:sp>
         <p:nvSpPr>
-          <p:cNvPr id="3" name="Text 1"/>
+          <p:cNvPr id="4" name="Text 1"/>
           <p:cNvSpPr/>
           <p:nvPr/>
         </p:nvSpPr>
         <p:spPr>
           <a:xfrm>
             <a:off x="320040" y="0"/>
-            <a:ext cx="3931920" cy="594360"/>
+            <a:ext cx="5029200" cy="594360"/>
           </a:xfrm>
           <a:prstGeom prst="rect">
             <a:avLst/>
@@ -1392,7 +1464,7 @@
               <a:buNone/>
             </a:pPr>
             <a:r>
-              <a:rPr lang="en-US" sz="2200" b="1" dirty="0">
+              <a:rPr lang="en-US" sz="2100" b="1" spc="100" kern="0" dirty="0">
                 <a:solidFill>
                   <a:srgbClr val="FFFFFF"/>
                 </a:solidFill>
@@ -1402,20 +1474,20 @@
               </a:rPr>
               <a:t>Concept A</a:t>
             </a:r>
-            <a:endParaRPr lang="en-US" sz="2200" dirty="0"/>
-          </a:p>
-        </p:txBody>
-      </p:sp>
-      <p:sp>
-        <p:nvSpPr>
-          <p:cNvPr id="4" name="Shape 2"/>
+            <a:endParaRPr lang="en-US" sz="2100" dirty="0"/>
+          </a:p>
+        </p:txBody>
+      </p:sp>
+      <p:sp>
+        <p:nvSpPr>
+          <p:cNvPr id="5" name="Shape 2"/>
           <p:cNvSpPr/>
           <p:nvPr/>
         </p:nvSpPr>
         <p:spPr>
           <a:xfrm>
             <a:off x="0" y="594360"/>
-            <a:ext cx="4480560" cy="2274570"/>
+            <a:ext cx="4434840" cy="2274570"/>
           </a:xfrm>
           <a:prstGeom prst="rect">
             <a:avLst/>
@@ -1425,7 +1497,7 @@
           </a:solidFill>
           <a:ln w="6350">
             <a:solidFill>
-              <a:srgbClr val="E8E4DF"/>
+              <a:srgbClr val="E8E3DD"/>
             </a:solidFill>
             <a:prstDash val="solid"/>
           </a:ln>
@@ -1433,14 +1505,14 @@
       </p:sp>
       <p:sp>
         <p:nvSpPr>
-          <p:cNvPr id="5" name="Text 3"/>
+          <p:cNvPr id="6" name="Text 3"/>
           <p:cNvSpPr/>
           <p:nvPr/>
         </p:nvSpPr>
         <p:spPr>
           <a:xfrm>
             <a:off x="91440" y="685800"/>
-            <a:ext cx="4297680" cy="256032"/>
+            <a:ext cx="4251960" cy="256032"/>
           </a:xfrm>
           <a:prstGeom prst="rect">
             <a:avLst/>
@@ -1456,7 +1528,7 @@
               <a:buNone/>
             </a:pPr>
             <a:r>
-              <a:rPr lang="en-US" sz="750" spc="250" kern="0" dirty="0">
+              <a:rPr lang="en-US" sz="700" spc="300" kern="0" dirty="0">
                 <a:solidFill>
                   <a:srgbClr val="AAAAAA"/>
                 </a:solidFill>
@@ -1466,20 +1538,20 @@
               </a:rPr>
               <a:t>LIGHT BACKGROUND</a:t>
             </a:r>
-            <a:endParaRPr lang="en-US" sz="750" dirty="0"/>
-          </a:p>
-        </p:txBody>
-      </p:sp>
-      <p:sp>
-        <p:nvSpPr>
-          <p:cNvPr id="6" name="Shape 4"/>
-          <p:cNvSpPr/>
-          <p:nvPr/>
-        </p:nvSpPr>
-        <p:spPr>
-          <a:xfrm>
-            <a:off x="1005840" y="1205865"/>
-            <a:ext cx="2468880" cy="1234440"/>
+            <a:endParaRPr lang="en-US" sz="700" dirty="0"/>
+          </a:p>
+        </p:txBody>
+      </p:sp>
+      <p:sp>
+        <p:nvSpPr>
+          <p:cNvPr id="7" name="Shape 4"/>
+          <p:cNvSpPr/>
+          <p:nvPr/>
+        </p:nvSpPr>
+        <p:spPr>
+          <a:xfrm>
+            <a:off x="960120" y="1228725"/>
+            <a:ext cx="2514600" cy="1188720"/>
           </a:xfrm>
           <a:prstGeom prst="rect">
             <a:avLst/>
@@ -1489,7 +1561,7 @@
           </a:solidFill>
           <a:ln w="9525">
             <a:solidFill>
-              <a:srgbClr val="CCCCCC"/>
+              <a:srgbClr val="C8C8C8"/>
             </a:solidFill>
             <a:prstDash val="dash"/>
           </a:ln>
@@ -1497,14 +1569,14 @@
       </p:sp>
       <p:sp>
         <p:nvSpPr>
-          <p:cNvPr id="7" name="Text 5"/>
-          <p:cNvSpPr/>
-          <p:nvPr/>
-        </p:nvSpPr>
-        <p:spPr>
-          <a:xfrm>
-            <a:off x="1005840" y="1205865"/>
-            <a:ext cx="2468880" cy="1234440"/>
+          <p:cNvPr id="8" name="Text 5"/>
+          <p:cNvSpPr/>
+          <p:nvPr/>
+        </p:nvSpPr>
+        <p:spPr>
+          <a:xfrm>
+            <a:off x="960120" y="1228725"/>
+            <a:ext cx="2514600" cy="1188720"/>
           </a:xfrm>
           <a:prstGeom prst="rect">
             <a:avLst/>
@@ -1520,7 +1592,7 @@
               <a:buNone/>
             </a:pPr>
             <a:r>
-              <a:rPr lang="en-US" sz="1050" i="1" dirty="0">
+              <a:rPr lang="en-US" sz="1000" i="1" dirty="0">
                 <a:solidFill>
                   <a:srgbClr val="AAAAAA"/>
                 </a:solidFill>
@@ -1530,20 +1602,20 @@
               </a:rPr>
               <a:t>Logo — Light Background</a:t>
             </a:r>
-            <a:endParaRPr lang="en-US" sz="1050" dirty="0"/>
-          </a:p>
-        </p:txBody>
-      </p:sp>
-      <p:sp>
-        <p:nvSpPr>
-          <p:cNvPr id="8" name="Shape 6"/>
+            <a:endParaRPr lang="en-US" sz="1000" dirty="0"/>
+          </a:p>
+        </p:txBody>
+      </p:sp>
+      <p:sp>
+        <p:nvSpPr>
+          <p:cNvPr id="9" name="Shape 6"/>
           <p:cNvSpPr/>
           <p:nvPr/>
         </p:nvSpPr>
         <p:spPr>
           <a:xfrm>
             <a:off x="0" y="2868930"/>
-            <a:ext cx="4480560" cy="2274570"/>
+            <a:ext cx="4434840" cy="2274570"/>
           </a:xfrm>
           <a:prstGeom prst="rect">
             <a:avLst/>
@@ -1561,14 +1633,14 @@
       </p:sp>
       <p:sp>
         <p:nvSpPr>
-          <p:cNvPr id="9" name="Text 7"/>
+          <p:cNvPr id="10" name="Text 7"/>
           <p:cNvSpPr/>
           <p:nvPr/>
         </p:nvSpPr>
         <p:spPr>
           <a:xfrm>
             <a:off x="91440" y="2960370"/>
-            <a:ext cx="4297680" cy="256032"/>
+            <a:ext cx="4251960" cy="256032"/>
           </a:xfrm>
           <a:prstGeom prst="rect">
             <a:avLst/>
@@ -1584,7 +1656,7 @@
               <a:buNone/>
             </a:pPr>
             <a:r>
-              <a:rPr lang="en-US" sz="750" spc="250" kern="0" dirty="0">
+              <a:rPr lang="en-US" sz="700" spc="300" kern="0" dirty="0">
                 <a:solidFill>
                   <a:srgbClr val="666666"/>
                 </a:solidFill>
@@ -1594,20 +1666,20 @@
               </a:rPr>
               <a:t>DARK BACKGROUND</a:t>
             </a:r>
-            <a:endParaRPr lang="en-US" sz="750" dirty="0"/>
-          </a:p>
-        </p:txBody>
-      </p:sp>
-      <p:sp>
-        <p:nvSpPr>
-          <p:cNvPr id="10" name="Shape 8"/>
-          <p:cNvSpPr/>
-          <p:nvPr/>
-        </p:nvSpPr>
-        <p:spPr>
-          <a:xfrm>
-            <a:off x="1005840" y="3480435"/>
-            <a:ext cx="2468880" cy="1234440"/>
+            <a:endParaRPr lang="en-US" sz="700" dirty="0"/>
+          </a:p>
+        </p:txBody>
+      </p:sp>
+      <p:sp>
+        <p:nvSpPr>
+          <p:cNvPr id="11" name="Shape 8"/>
+          <p:cNvSpPr/>
+          <p:nvPr/>
+        </p:nvSpPr>
+        <p:spPr>
+          <a:xfrm>
+            <a:off x="960120" y="3503295"/>
+            <a:ext cx="2514600" cy="1188720"/>
           </a:xfrm>
           <a:prstGeom prst="rect">
             <a:avLst/>
@@ -1625,14 +1697,14 @@
       </p:sp>
       <p:sp>
         <p:nvSpPr>
-          <p:cNvPr id="11" name="Text 9"/>
-          <p:cNvSpPr/>
-          <p:nvPr/>
-        </p:nvSpPr>
-        <p:spPr>
-          <a:xfrm>
-            <a:off x="1005840" y="3480435"/>
-            <a:ext cx="2468880" cy="1234440"/>
+          <p:cNvPr id="12" name="Text 9"/>
+          <p:cNvSpPr/>
+          <p:nvPr/>
+        </p:nvSpPr>
+        <p:spPr>
+          <a:xfrm>
+            <a:off x="960120" y="3503295"/>
+            <a:ext cx="2514600" cy="1188720"/>
           </a:xfrm>
           <a:prstGeom prst="rect">
             <a:avLst/>
@@ -1648,7 +1720,7 @@
               <a:buNone/>
             </a:pPr>
             <a:r>
-              <a:rPr lang="en-US" sz="1050" i="1" dirty="0">
+              <a:rPr lang="en-US" sz="1000" i="1" dirty="0">
                 <a:solidFill>
                   <a:srgbClr val="666666"/>
                 </a:solidFill>
@@ -1658,19 +1730,19 @@
               </a:rPr>
               <a:t>Logo — Dark Background</a:t>
             </a:r>
-            <a:endParaRPr lang="en-US" sz="1050" dirty="0"/>
-          </a:p>
-        </p:txBody>
-      </p:sp>
-      <p:sp>
-        <p:nvSpPr>
-          <p:cNvPr id="12" name="Shape 10"/>
-          <p:cNvSpPr/>
-          <p:nvPr/>
-        </p:nvSpPr>
-        <p:spPr>
-          <a:xfrm>
-            <a:off x="4480560" y="594360"/>
+            <a:endParaRPr lang="en-US" sz="1000" dirty="0"/>
+          </a:p>
+        </p:txBody>
+      </p:sp>
+      <p:sp>
+        <p:nvSpPr>
+          <p:cNvPr id="13" name="Shape 10"/>
+          <p:cNvSpPr/>
+          <p:nvPr/>
+        </p:nvSpPr>
+        <p:spPr>
+          <a:xfrm>
+            <a:off x="4434840" y="594360"/>
             <a:ext cx="0" cy="4549140"/>
           </a:xfrm>
           <a:prstGeom prst="line">
@@ -1687,14 +1759,14 @@
       </p:sp>
       <p:sp>
         <p:nvSpPr>
-          <p:cNvPr id="13" name="Text 11"/>
-          <p:cNvSpPr/>
-          <p:nvPr/>
-        </p:nvSpPr>
-        <p:spPr>
-          <a:xfrm>
-            <a:off x="4773168" y="868680"/>
-            <a:ext cx="4251960" cy="411480"/>
+          <p:cNvPr id="14" name="Text 11"/>
+          <p:cNvSpPr/>
+          <p:nvPr/>
+        </p:nvSpPr>
+        <p:spPr>
+          <a:xfrm>
+            <a:off x="4709160" y="841248"/>
+            <a:ext cx="4325112" cy="402336"/>
           </a:xfrm>
           <a:prstGeom prst="rect">
             <a:avLst/>
@@ -1726,13 +1798,13 @@
       </p:sp>
       <p:sp>
         <p:nvSpPr>
-          <p:cNvPr id="14" name="Shape 12"/>
-          <p:cNvSpPr/>
-          <p:nvPr/>
-        </p:nvSpPr>
-        <p:spPr>
-          <a:xfrm>
-            <a:off x="4773168" y="1344168"/>
+          <p:cNvPr id="15" name="Shape 12"/>
+          <p:cNvSpPr/>
+          <p:nvPr/>
+        </p:nvSpPr>
+        <p:spPr>
+          <a:xfrm>
+            <a:off x="4709160" y="1307592"/>
             <a:ext cx="1280160" cy="0"/>
           </a:xfrm>
           <a:prstGeom prst="line">
@@ -1749,14 +1821,14 @@
       </p:sp>
       <p:sp>
         <p:nvSpPr>
-          <p:cNvPr id="15" name="Text 13"/>
-          <p:cNvSpPr/>
-          <p:nvPr/>
-        </p:nvSpPr>
-        <p:spPr>
-          <a:xfrm>
-            <a:off x="4773168" y="1508760"/>
-            <a:ext cx="4251960" cy="3200400"/>
+          <p:cNvPr id="16" name="Text 13"/>
+          <p:cNvSpPr/>
+          <p:nvPr/>
+        </p:nvSpPr>
+        <p:spPr>
+          <a:xfrm>
+            <a:off x="4709160" y="1463040"/>
+            <a:ext cx="4325112" cy="3291840"/>
           </a:xfrm>
           <a:prstGeom prst="rect">
             <a:avLst/>
@@ -1770,12 +1842,12 @@
           <a:p>
             <a:pPr algn="l" indent="0" marL="0">
               <a:lnSpc>
-                <a:spcPct val="145000"/>
+                <a:spcPct val="150000"/>
               </a:lnSpc>
               <a:buNone/>
             </a:pPr>
             <a:r>
-              <a:rPr lang="en-US" sz="1300" i="1" dirty="0">
+              <a:rPr lang="en-US" sz="1250" i="1" dirty="0">
                 <a:solidFill>
                   <a:srgbClr val="999999"/>
                 </a:solidFill>
@@ -1785,7 +1857,7 @@
               </a:rPr>
               <a:t>Describe the thinking behind this concept — what it represents, why the form and feeling fit the brief, how it connects to the SXSW-meets-Coachella energy of Project AIR.</a:t>
             </a:r>
-            <a:endParaRPr lang="en-US" sz="1300" dirty="0"/>
+            <a:endParaRPr lang="en-US" sz="1250" dirty="0"/>
           </a:p>
         </p:txBody>
       </p:sp>
@@ -1821,9 +1893,33 @@
           <a:chExt cx="0" cy="0"/>
         </a:xfrm>
       </p:grpSpPr>
-      <p:sp>
-        <p:nvSpPr>
-          <p:cNvPr id="2" name="Shape 0"/>
+      <p:pic>
+        <p:nvPicPr>
+          <p:cNvPr id="2" name="Image 0" descr="preencoded.png">    </p:cNvPr>
+          <p:cNvPicPr>
+            <a:picLocks noChangeAspect="1"/>
+          </p:cNvPicPr>
+          <p:nvPr/>
+        </p:nvPicPr>
+        <p:blipFill>
+          <a:blip r:embed="rId1"/>
+          <a:stretch>
+            <a:fillRect/>
+          </a:stretch>
+        </p:blipFill>
+        <p:spPr>
+          <a:xfrm>
+            <a:off x="6903720" y="0"/>
+            <a:ext cx="2240280" cy="2240280"/>
+          </a:xfrm>
+          <a:prstGeom prst="rect">
+            <a:avLst/>
+          </a:prstGeom>
+        </p:spPr>
+      </p:pic>
+      <p:sp>
+        <p:nvSpPr>
+          <p:cNvPr id="3" name="Shape 0"/>
           <p:cNvSpPr/>
           <p:nvPr/>
         </p:nvSpPr>
@@ -1848,14 +1944,14 @@
       </p:sp>
       <p:sp>
         <p:nvSpPr>
-          <p:cNvPr id="3" name="Text 1"/>
+          <p:cNvPr id="4" name="Text 1"/>
           <p:cNvSpPr/>
           <p:nvPr/>
         </p:nvSpPr>
         <p:spPr>
           <a:xfrm>
             <a:off x="320040" y="0"/>
-            <a:ext cx="3931920" cy="594360"/>
+            <a:ext cx="5029200" cy="594360"/>
           </a:xfrm>
           <a:prstGeom prst="rect">
             <a:avLst/>
@@ -1871,7 +1967,7 @@
               <a:buNone/>
             </a:pPr>
             <a:r>
-              <a:rPr lang="en-US" sz="2200" b="1" dirty="0">
+              <a:rPr lang="en-US" sz="2100" b="1" spc="100" kern="0" dirty="0">
                 <a:solidFill>
                   <a:srgbClr val="FFFFFF"/>
                 </a:solidFill>
@@ -1881,20 +1977,20 @@
               </a:rPr>
               <a:t>Concept B</a:t>
             </a:r>
-            <a:endParaRPr lang="en-US" sz="2200" dirty="0"/>
-          </a:p>
-        </p:txBody>
-      </p:sp>
-      <p:sp>
-        <p:nvSpPr>
-          <p:cNvPr id="4" name="Shape 2"/>
+            <a:endParaRPr lang="en-US" sz="2100" dirty="0"/>
+          </a:p>
+        </p:txBody>
+      </p:sp>
+      <p:sp>
+        <p:nvSpPr>
+          <p:cNvPr id="5" name="Shape 2"/>
           <p:cNvSpPr/>
           <p:nvPr/>
         </p:nvSpPr>
         <p:spPr>
           <a:xfrm>
             <a:off x="0" y="594360"/>
-            <a:ext cx="4480560" cy="2274570"/>
+            <a:ext cx="4434840" cy="2274570"/>
           </a:xfrm>
           <a:prstGeom prst="rect">
             <a:avLst/>
@@ -1904,7 +2000,7 @@
           </a:solidFill>
           <a:ln w="6350">
             <a:solidFill>
-              <a:srgbClr val="E8E4DF"/>
+              <a:srgbClr val="E8E3DD"/>
             </a:solidFill>
             <a:prstDash val="solid"/>
           </a:ln>
@@ -1912,14 +2008,14 @@
       </p:sp>
       <p:sp>
         <p:nvSpPr>
-          <p:cNvPr id="5" name="Text 3"/>
+          <p:cNvPr id="6" name="Text 3"/>
           <p:cNvSpPr/>
           <p:nvPr/>
         </p:nvSpPr>
         <p:spPr>
           <a:xfrm>
             <a:off x="91440" y="685800"/>
-            <a:ext cx="4297680" cy="256032"/>
+            <a:ext cx="4251960" cy="256032"/>
           </a:xfrm>
           <a:prstGeom prst="rect">
             <a:avLst/>
@@ -1935,7 +2031,7 @@
               <a:buNone/>
             </a:pPr>
             <a:r>
-              <a:rPr lang="en-US" sz="750" spc="250" kern="0" dirty="0">
+              <a:rPr lang="en-US" sz="700" spc="300" kern="0" dirty="0">
                 <a:solidFill>
                   <a:srgbClr val="AAAAAA"/>
                 </a:solidFill>
@@ -1945,20 +2041,20 @@
               </a:rPr>
               <a:t>LIGHT BACKGROUND</a:t>
             </a:r>
-            <a:endParaRPr lang="en-US" sz="750" dirty="0"/>
-          </a:p>
-        </p:txBody>
-      </p:sp>
-      <p:sp>
-        <p:nvSpPr>
-          <p:cNvPr id="6" name="Shape 4"/>
-          <p:cNvSpPr/>
-          <p:nvPr/>
-        </p:nvSpPr>
-        <p:spPr>
-          <a:xfrm>
-            <a:off x="1005840" y="1205865"/>
-            <a:ext cx="2468880" cy="1234440"/>
+            <a:endParaRPr lang="en-US" sz="700" dirty="0"/>
+          </a:p>
+        </p:txBody>
+      </p:sp>
+      <p:sp>
+        <p:nvSpPr>
+          <p:cNvPr id="7" name="Shape 4"/>
+          <p:cNvSpPr/>
+          <p:nvPr/>
+        </p:nvSpPr>
+        <p:spPr>
+          <a:xfrm>
+            <a:off x="960120" y="1228725"/>
+            <a:ext cx="2514600" cy="1188720"/>
           </a:xfrm>
           <a:prstGeom prst="rect">
             <a:avLst/>
@@ -1968,7 +2064,7 @@
           </a:solidFill>
           <a:ln w="9525">
             <a:solidFill>
-              <a:srgbClr val="CCCCCC"/>
+              <a:srgbClr val="C8C8C8"/>
             </a:solidFill>
             <a:prstDash val="dash"/>
           </a:ln>
@@ -1976,14 +2072,14 @@
       </p:sp>
       <p:sp>
         <p:nvSpPr>
-          <p:cNvPr id="7" name="Text 5"/>
-          <p:cNvSpPr/>
-          <p:nvPr/>
-        </p:nvSpPr>
-        <p:spPr>
-          <a:xfrm>
-            <a:off x="1005840" y="1205865"/>
-            <a:ext cx="2468880" cy="1234440"/>
+          <p:cNvPr id="8" name="Text 5"/>
+          <p:cNvSpPr/>
+          <p:nvPr/>
+        </p:nvSpPr>
+        <p:spPr>
+          <a:xfrm>
+            <a:off x="960120" y="1228725"/>
+            <a:ext cx="2514600" cy="1188720"/>
           </a:xfrm>
           <a:prstGeom prst="rect">
             <a:avLst/>
@@ -1999,7 +2095,7 @@
               <a:buNone/>
             </a:pPr>
             <a:r>
-              <a:rPr lang="en-US" sz="1050" i="1" dirty="0">
+              <a:rPr lang="en-US" sz="1000" i="1" dirty="0">
                 <a:solidFill>
                   <a:srgbClr val="AAAAAA"/>
                 </a:solidFill>
@@ -2009,20 +2105,20 @@
               </a:rPr>
               <a:t>Logo — Light Background</a:t>
             </a:r>
-            <a:endParaRPr lang="en-US" sz="1050" dirty="0"/>
-          </a:p>
-        </p:txBody>
-      </p:sp>
-      <p:sp>
-        <p:nvSpPr>
-          <p:cNvPr id="8" name="Shape 6"/>
+            <a:endParaRPr lang="en-US" sz="1000" dirty="0"/>
+          </a:p>
+        </p:txBody>
+      </p:sp>
+      <p:sp>
+        <p:nvSpPr>
+          <p:cNvPr id="9" name="Shape 6"/>
           <p:cNvSpPr/>
           <p:nvPr/>
         </p:nvSpPr>
         <p:spPr>
           <a:xfrm>
             <a:off x="0" y="2868930"/>
-            <a:ext cx="4480560" cy="2274570"/>
+            <a:ext cx="4434840" cy="2274570"/>
           </a:xfrm>
           <a:prstGeom prst="rect">
             <a:avLst/>
@@ -2040,14 +2136,14 @@
       </p:sp>
       <p:sp>
         <p:nvSpPr>
-          <p:cNvPr id="9" name="Text 7"/>
+          <p:cNvPr id="10" name="Text 7"/>
           <p:cNvSpPr/>
           <p:nvPr/>
         </p:nvSpPr>
         <p:spPr>
           <a:xfrm>
             <a:off x="91440" y="2960370"/>
-            <a:ext cx="4297680" cy="256032"/>
+            <a:ext cx="4251960" cy="256032"/>
           </a:xfrm>
           <a:prstGeom prst="rect">
             <a:avLst/>
@@ -2063,7 +2159,7 @@
               <a:buNone/>
             </a:pPr>
             <a:r>
-              <a:rPr lang="en-US" sz="750" spc="250" kern="0" dirty="0">
+              <a:rPr lang="en-US" sz="700" spc="300" kern="0" dirty="0">
                 <a:solidFill>
                   <a:srgbClr val="666666"/>
                 </a:solidFill>
@@ -2073,20 +2169,20 @@
               </a:rPr>
               <a:t>DARK BACKGROUND</a:t>
             </a:r>
-            <a:endParaRPr lang="en-US" sz="750" dirty="0"/>
-          </a:p>
-        </p:txBody>
-      </p:sp>
-      <p:sp>
-        <p:nvSpPr>
-          <p:cNvPr id="10" name="Shape 8"/>
-          <p:cNvSpPr/>
-          <p:nvPr/>
-        </p:nvSpPr>
-        <p:spPr>
-          <a:xfrm>
-            <a:off x="1005840" y="3480435"/>
-            <a:ext cx="2468880" cy="1234440"/>
+            <a:endParaRPr lang="en-US" sz="700" dirty="0"/>
+          </a:p>
+        </p:txBody>
+      </p:sp>
+      <p:sp>
+        <p:nvSpPr>
+          <p:cNvPr id="11" name="Shape 8"/>
+          <p:cNvSpPr/>
+          <p:nvPr/>
+        </p:nvSpPr>
+        <p:spPr>
+          <a:xfrm>
+            <a:off x="960120" y="3503295"/>
+            <a:ext cx="2514600" cy="1188720"/>
           </a:xfrm>
           <a:prstGeom prst="rect">
             <a:avLst/>
@@ -2104,14 +2200,14 @@
       </p:sp>
       <p:sp>
         <p:nvSpPr>
-          <p:cNvPr id="11" name="Text 9"/>
-          <p:cNvSpPr/>
-          <p:nvPr/>
-        </p:nvSpPr>
-        <p:spPr>
-          <a:xfrm>
-            <a:off x="1005840" y="3480435"/>
-            <a:ext cx="2468880" cy="1234440"/>
+          <p:cNvPr id="12" name="Text 9"/>
+          <p:cNvSpPr/>
+          <p:nvPr/>
+        </p:nvSpPr>
+        <p:spPr>
+          <a:xfrm>
+            <a:off x="960120" y="3503295"/>
+            <a:ext cx="2514600" cy="1188720"/>
           </a:xfrm>
           <a:prstGeom prst="rect">
             <a:avLst/>
@@ -2127,7 +2223,7 @@
               <a:buNone/>
             </a:pPr>
             <a:r>
-              <a:rPr lang="en-US" sz="1050" i="1" dirty="0">
+              <a:rPr lang="en-US" sz="1000" i="1" dirty="0">
                 <a:solidFill>
                   <a:srgbClr val="666666"/>
                 </a:solidFill>
@@ -2137,19 +2233,19 @@
               </a:rPr>
               <a:t>Logo — Dark Background</a:t>
             </a:r>
-            <a:endParaRPr lang="en-US" sz="1050" dirty="0"/>
-          </a:p>
-        </p:txBody>
-      </p:sp>
-      <p:sp>
-        <p:nvSpPr>
-          <p:cNvPr id="12" name="Shape 10"/>
-          <p:cNvSpPr/>
-          <p:nvPr/>
-        </p:nvSpPr>
-        <p:spPr>
-          <a:xfrm>
-            <a:off x="4480560" y="594360"/>
+            <a:endParaRPr lang="en-US" sz="1000" dirty="0"/>
+          </a:p>
+        </p:txBody>
+      </p:sp>
+      <p:sp>
+        <p:nvSpPr>
+          <p:cNvPr id="13" name="Shape 10"/>
+          <p:cNvSpPr/>
+          <p:nvPr/>
+        </p:nvSpPr>
+        <p:spPr>
+          <a:xfrm>
+            <a:off x="4434840" y="594360"/>
             <a:ext cx="0" cy="4549140"/>
           </a:xfrm>
           <a:prstGeom prst="line">
@@ -2166,14 +2262,14 @@
       </p:sp>
       <p:sp>
         <p:nvSpPr>
-          <p:cNvPr id="13" name="Text 11"/>
-          <p:cNvSpPr/>
-          <p:nvPr/>
-        </p:nvSpPr>
-        <p:spPr>
-          <a:xfrm>
-            <a:off x="4773168" y="868680"/>
-            <a:ext cx="4251960" cy="411480"/>
+          <p:cNvPr id="14" name="Text 11"/>
+          <p:cNvSpPr/>
+          <p:nvPr/>
+        </p:nvSpPr>
+        <p:spPr>
+          <a:xfrm>
+            <a:off x="4709160" y="841248"/>
+            <a:ext cx="4325112" cy="402336"/>
           </a:xfrm>
           <a:prstGeom prst="rect">
             <a:avLst/>
@@ -2205,13 +2301,13 @@
       </p:sp>
       <p:sp>
         <p:nvSpPr>
-          <p:cNvPr id="14" name="Shape 12"/>
-          <p:cNvSpPr/>
-          <p:nvPr/>
-        </p:nvSpPr>
-        <p:spPr>
-          <a:xfrm>
-            <a:off x="4773168" y="1344168"/>
+          <p:cNvPr id="15" name="Shape 12"/>
+          <p:cNvSpPr/>
+          <p:nvPr/>
+        </p:nvSpPr>
+        <p:spPr>
+          <a:xfrm>
+            <a:off x="4709160" y="1307592"/>
             <a:ext cx="1280160" cy="0"/>
           </a:xfrm>
           <a:prstGeom prst="line">
@@ -2228,14 +2324,14 @@
       </p:sp>
       <p:sp>
         <p:nvSpPr>
-          <p:cNvPr id="15" name="Text 13"/>
-          <p:cNvSpPr/>
-          <p:nvPr/>
-        </p:nvSpPr>
-        <p:spPr>
-          <a:xfrm>
-            <a:off x="4773168" y="1508760"/>
-            <a:ext cx="4251960" cy="3200400"/>
+          <p:cNvPr id="16" name="Text 13"/>
+          <p:cNvSpPr/>
+          <p:nvPr/>
+        </p:nvSpPr>
+        <p:spPr>
+          <a:xfrm>
+            <a:off x="4709160" y="1463040"/>
+            <a:ext cx="4325112" cy="3291840"/>
           </a:xfrm>
           <a:prstGeom prst="rect">
             <a:avLst/>
@@ -2249,12 +2345,12 @@
           <a:p>
             <a:pPr algn="l" indent="0" marL="0">
               <a:lnSpc>
-                <a:spcPct val="145000"/>
+                <a:spcPct val="150000"/>
               </a:lnSpc>
               <a:buNone/>
             </a:pPr>
             <a:r>
-              <a:rPr lang="en-US" sz="1300" i="1" dirty="0">
+              <a:rPr lang="en-US" sz="1250" i="1" dirty="0">
                 <a:solidFill>
                   <a:srgbClr val="999999"/>
                 </a:solidFill>
@@ -2264,7 +2360,7 @@
               </a:rPr>
               <a:t>Describe the thinking behind this concept — what it represents, why the form and feeling fit the brief, how it connects to the SXSW-meets-Coachella energy of Project AIR.</a:t>
             </a:r>
-            <a:endParaRPr lang="en-US" sz="1300" dirty="0"/>
+            <a:endParaRPr lang="en-US" sz="1250" dirty="0"/>
           </a:p>
         </p:txBody>
       </p:sp>
@@ -2300,16 +2396,40 @@
           <a:chExt cx="0" cy="0"/>
         </a:xfrm>
       </p:grpSpPr>
-      <p:sp>
-        <p:nvSpPr>
-          <p:cNvPr id="2" name="Shape 0"/>
+      <p:pic>
+        <p:nvPicPr>
+          <p:cNvPr id="2" name="Image 0" descr="preencoded.png">    </p:cNvPr>
+          <p:cNvPicPr>
+            <a:picLocks noChangeAspect="1"/>
+          </p:cNvPicPr>
+          <p:nvPr/>
+        </p:nvPicPr>
+        <p:blipFill>
+          <a:blip r:embed="rId1"/>
+          <a:stretch>
+            <a:fillRect/>
+          </a:stretch>
+        </p:blipFill>
+        <p:spPr>
+          <a:xfrm>
+            <a:off x="6903720" y="2857500"/>
+            <a:ext cx="2240280" cy="2286000"/>
+          </a:xfrm>
+          <a:prstGeom prst="rect">
+            <a:avLst/>
+          </a:prstGeom>
+        </p:spPr>
+      </p:pic>
+      <p:sp>
+        <p:nvSpPr>
+          <p:cNvPr id="3" name="Shape 0"/>
           <p:cNvSpPr/>
           <p:nvPr/>
         </p:nvSpPr>
         <p:spPr>
           <a:xfrm>
             <a:off x="0" y="0"/>
-            <a:ext cx="292608" cy="5143500"/>
+            <a:ext cx="256032" cy="5143500"/>
           </a:xfrm>
           <a:prstGeom prst="rect">
             <a:avLst/>
@@ -2327,14 +2447,14 @@
       </p:sp>
       <p:sp>
         <p:nvSpPr>
-          <p:cNvPr id="3" name="Text 1"/>
-          <p:cNvSpPr/>
-          <p:nvPr/>
-        </p:nvSpPr>
-        <p:spPr>
-          <a:xfrm>
-            <a:off x="548640" y="365760"/>
-            <a:ext cx="8229600" cy="731520"/>
+          <p:cNvPr id="4" name="Text 1"/>
+          <p:cNvSpPr/>
+          <p:nvPr/>
+        </p:nvSpPr>
+        <p:spPr>
+          <a:xfrm>
+            <a:off x="502920" y="347472"/>
+            <a:ext cx="8229600" cy="777240"/>
           </a:xfrm>
           <a:prstGeom prst="rect">
             <a:avLst/>
@@ -2350,7 +2470,7 @@
               <a:buNone/>
             </a:pPr>
             <a:r>
-              <a:rPr lang="en-US" sz="3800" b="1" dirty="0">
+              <a:rPr lang="en-US" sz="4200" b="1" spc="400" kern="0" dirty="0">
                 <a:solidFill>
                   <a:srgbClr val="FFFFFF"/>
                 </a:solidFill>
@@ -2358,22 +2478,22 @@
                 <a:ea typeface="Calibri" pitchFamily="34" charset="-122"/>
                 <a:cs typeface="Calibri" pitchFamily="34" charset="-120"/>
               </a:rPr>
-              <a:t>Next Steps</a:t>
-            </a:r>
-            <a:endParaRPr lang="en-US" sz="3800" dirty="0"/>
-          </a:p>
-        </p:txBody>
-      </p:sp>
-      <p:sp>
-        <p:nvSpPr>
-          <p:cNvPr id="4" name="Shape 2"/>
-          <p:cNvSpPr/>
-          <p:nvPr/>
-        </p:nvSpPr>
-        <p:spPr>
-          <a:xfrm>
-            <a:off x="548640" y="1207008"/>
-            <a:ext cx="1828800" cy="0"/>
+              <a:t>NEXT STEPS</a:t>
+            </a:r>
+            <a:endParaRPr lang="en-US" sz="4200" dirty="0"/>
+          </a:p>
+        </p:txBody>
+      </p:sp>
+      <p:sp>
+        <p:nvSpPr>
+          <p:cNvPr id="5" name="Shape 2"/>
+          <p:cNvSpPr/>
+          <p:nvPr/>
+        </p:nvSpPr>
+        <p:spPr>
+          <a:xfrm>
+            <a:off x="502920" y="1234440"/>
+            <a:ext cx="2011680" cy="0"/>
           </a:xfrm>
           <a:prstGeom prst="line">
             <a:avLst/>
@@ -2389,14 +2509,14 @@
       </p:sp>
       <p:sp>
         <p:nvSpPr>
-          <p:cNvPr id="5" name="Text 3"/>
-          <p:cNvSpPr/>
-          <p:nvPr/>
-        </p:nvSpPr>
-        <p:spPr>
-          <a:xfrm>
-            <a:off x="548640" y="1389888"/>
-            <a:ext cx="8229600" cy="3474720"/>
+          <p:cNvPr id="6" name="Text 3"/>
+          <p:cNvSpPr/>
+          <p:nvPr/>
+        </p:nvSpPr>
+        <p:spPr>
+          <a:xfrm>
+            <a:off x="502920" y="1417320"/>
+            <a:ext cx="6400800" cy="3429000"/>
           </a:xfrm>
           <a:prstGeom prst="rect">
             <a:avLst/>

</xml_diff>

<commit_message>
Sync all local files — calendar, PPTX, patterns, build script
- Campaign calendar fully updated to match program tracker (May 11 sync)
- New dates: logo May 12, swag May 15, poster system May 18, animation/PPT May 20, poster review May 21, Atlas cutoff May 22
- Maigh confirmed for headshots only, ambassador list flagged unassigned
- Google Sheets link added to calendar header
- Logo presentation PPTX updated (Google Slides SVG fix applied)
- Logo presentation backup added
- Build script updated
- Patterns folder added (SVG + EMF pattern assets)

Co-Authored-By: Claude Sonnet 4.5 <noreply@anthropic.com>
</commit_message>
<xml_diff>
--- a/assets/templates/logo-presentation.pptx
+++ b/assets/templates/logo-presentation.pptx
@@ -4,16 +4,16 @@
   <p:sldMasterIdLst>
     <p:sldMasterId id="2147483648" r:id="rId1"/>
   </p:sldMasterIdLst>
+  <p:notesMasterIdLst>
+    <p:notesMasterId r:id="rId6"/>
+  </p:notesMasterIdLst>
   <p:sldIdLst>
     <p:sldId id="256" r:id="rId2"/>
     <p:sldId id="257" r:id="rId3"/>
     <p:sldId id="258" r:id="rId4"/>
     <p:sldId id="259" r:id="rId5"/>
   </p:sldIdLst>
-  <p:notesMasterIdLst>
-    <p:notesMasterId r:id="rId6"/>
-  </p:notesMasterIdLst>
-  <p:sldSz cx="9144000" cy="5143500"/>
+  <p:sldSz cx="9144000" cy="5143500" type="screen16x9"/>
   <p:notesSz cx="5143500" cy="9144000"/>
   <p:defaultTextStyle>
     <a:lvl1pPr marL="0" algn="l" defTabSz="914400" rtl="0" eaLnBrk="1" latinLnBrk="0" hangingPunct="1">
@@ -107,6 +107,11 @@
       </a:defRPr>
     </a:lvl9pPr>
   </p:defaultTextStyle>
+  <p:extLst>
+    <p:ext uri="{EFAFB233-063F-42B5-8137-9DF3F51BA10A}">
+      <p15:sldGuideLst xmlns:p15="http://schemas.microsoft.com/office/powerpoint/2012/main"/>
+    </p:ext>
+  </p:extLst>
 </p:presentation>
 </file>
 
@@ -132,234 +137,10 @@
           <a:chExt cx="0" cy="0"/>
         </a:xfrm>
       </p:grpSpPr>
-      <p:sp>
-        <p:nvSpPr>
-          <p:cNvPr id="2" name="Header Placeholder 1"/>
-          <p:cNvSpPr>
-            <a:spLocks noGrp="1"/>
-          </p:cNvSpPr>
-          <p:nvPr>
-            <p:ph type="hdr" sz="quarter"/>
-          </p:nvPr>
-        </p:nvSpPr>
-        <p:spPr>
-          <a:xfrm>
-            <a:off x="0" y="0"/>
-            <a:ext cx="2971800" cy="458788"/>
-          </a:xfrm>
-          <a:prstGeom prst="rect">
-            <a:avLst/>
-          </a:prstGeom>
-        </p:spPr>
-        <p:txBody>
-          <a:bodyPr vert="horz" lIns="91440" tIns="45720" rIns="91440" bIns="45720" rtlCol="0"/>
-          <a:lstStyle>
-            <a:lvl1pPr algn="l">
-              <a:defRPr sz="1200"/>
-            </a:lvl1pPr>
-          </a:lstStyle>
-          <a:p>
-            <a:endParaRPr lang="en-US"/>
-          </a:p>
-        </p:txBody>
-      </p:sp>
-      <p:sp>
-        <p:nvSpPr>
-          <p:cNvPr id="3" name="Date Placeholder 2"/>
-          <p:cNvSpPr>
-            <a:spLocks noGrp="1"/>
-          </p:cNvSpPr>
-          <p:nvPr>
-            <p:ph type="dt" idx="1"/>
-          </p:nvPr>
-        </p:nvSpPr>
-        <p:spPr>
-          <a:xfrm>
-            <a:off x="3884613" y="0"/>
-            <a:ext cx="2971800" cy="458788"/>
-          </a:xfrm>
-          <a:prstGeom prst="rect">
-            <a:avLst/>
-          </a:prstGeom>
-        </p:spPr>
-        <p:txBody>
-          <a:bodyPr vert="horz" lIns="91440" tIns="45720" rIns="91440" bIns="45720" rtlCol="0"/>
-          <a:lstStyle>
-            <a:lvl1pPr algn="r">
-              <a:defRPr sz="1200"/>
-            </a:lvl1pPr>
-          </a:lstStyle>
-          <a:p>
-            <a:fld id="{5282F153-3F37-0F45-9E97-73ACFA13230C}" type="datetimeFigureOut">
-              <a:rPr lang="en-US"/>
-              <a:t>7/23/19</a:t>
-            </a:fld>
-            <a:endParaRPr lang="en-US"/>
-          </a:p>
-        </p:txBody>
-      </p:sp>
-      <p:sp>
-        <p:nvSpPr>
-          <p:cNvPr id="4" name="Slide Image Placeholder 3"/>
-          <p:cNvSpPr>
-            <a:spLocks noGrp="1" noRot="1" noChangeAspect="1"/>
-          </p:cNvSpPr>
-          <p:nvPr>
-            <p:ph type="sldImg" idx="2"/>
-          </p:nvPr>
-        </p:nvSpPr>
-        <p:spPr>
-          <a:xfrm>
-            <a:off x="685800" y="1143000"/>
-            <a:ext cx="5486400" cy="3086100"/>
-          </a:xfrm>
-          <a:prstGeom prst="rect">
-            <a:avLst/>
-          </a:prstGeom>
-          <a:noFill/>
-          <a:ln w="12700">
-            <a:solidFill>
-              <a:prstClr val="black"/>
-            </a:solidFill>
-          </a:ln>
-        </p:spPr>
-        <p:txBody>
-          <a:bodyPr vert="horz" lIns="91440" tIns="45720" rIns="91440" bIns="45720" rtlCol="0" anchor="ctr"/>
-          <a:lstStyle/>
-          <a:p>
-            <a:endParaRPr lang="en-US"/>
-          </a:p>
-        </p:txBody>
-      </p:sp>
-      <p:sp>
-        <p:nvSpPr>
-          <p:cNvPr id="5" name="Notes Placeholder 4"/>
-          <p:cNvSpPr>
-            <a:spLocks noGrp="1"/>
-          </p:cNvSpPr>
-          <p:nvPr>
-            <p:ph type="body" sz="quarter" idx="3"/>
-          </p:nvPr>
-        </p:nvSpPr>
-        <p:spPr>
-          <a:xfrm>
-            <a:off x="685800" y="4400550"/>
-            <a:ext cx="5486400" cy="3600450"/>
-          </a:xfrm>
-          <a:prstGeom prst="rect">
-            <a:avLst/>
-          </a:prstGeom>
-        </p:spPr>
-        <p:txBody>
-          <a:bodyPr vert="horz" lIns="91440" tIns="45720" rIns="91440" bIns="45720" rtlCol="0"/>
-          <a:lstStyle/>
-          <a:p>
-            <a:pPr lvl="0"/>
-            <a:r>
-              <a:rPr lang="en-US"/>
-              <a:t>Click to edit Master text styles</a:t>
-            </a:r>
-          </a:p>
-          <a:p>
-            <a:pPr lvl="1"/>
-            <a:r>
-              <a:rPr lang="en-US"/>
-              <a:t>Second level</a:t>
-            </a:r>
-          </a:p>
-          <a:p>
-            <a:pPr lvl="2"/>
-            <a:r>
-              <a:rPr lang="en-US"/>
-              <a:t>Third level</a:t>
-            </a:r>
-          </a:p>
-          <a:p>
-            <a:pPr lvl="3"/>
-            <a:r>
-              <a:rPr lang="en-US"/>
-              <a:t>Fourth level</a:t>
-            </a:r>
-          </a:p>
-          <a:p>
-            <a:pPr lvl="4"/>
-            <a:r>
-              <a:rPr lang="en-US"/>
-              <a:t>Fifth level</a:t>
-            </a:r>
-          </a:p>
-        </p:txBody>
-      </p:sp>
-      <p:sp>
-        <p:nvSpPr>
-          <p:cNvPr id="6" name="Footer Placeholder 5"/>
-          <p:cNvSpPr>
-            <a:spLocks noGrp="1"/>
-          </p:cNvSpPr>
-          <p:nvPr>
-            <p:ph type="ftr" sz="quarter" idx="4"/>
-          </p:nvPr>
-        </p:nvSpPr>
-        <p:spPr>
-          <a:xfrm>
-            <a:off x="0" y="8685213"/>
-            <a:ext cx="2971800" cy="458787"/>
-          </a:xfrm>
-          <a:prstGeom prst="rect">
-            <a:avLst/>
-          </a:prstGeom>
-        </p:spPr>
-        <p:txBody>
-          <a:bodyPr vert="horz" lIns="91440" tIns="45720" rIns="91440" bIns="45720" rtlCol="0" anchor="b"/>
-          <a:lstStyle>
-            <a:lvl1pPr algn="l">
-              <a:defRPr sz="1200"/>
-            </a:lvl1pPr>
-          </a:lstStyle>
-          <a:p>
-            <a:endParaRPr lang="en-US"/>
-          </a:p>
-        </p:txBody>
-      </p:sp>
-      <p:sp>
-        <p:nvSpPr>
-          <p:cNvPr id="7" name="Slide Number Placeholder 6"/>
-          <p:cNvSpPr>
-            <a:spLocks noGrp="1"/>
-          </p:cNvSpPr>
-          <p:nvPr>
-            <p:ph type="sldNum" sz="quarter" idx="5"/>
-          </p:nvPr>
-        </p:nvSpPr>
-        <p:spPr>
-          <a:xfrm>
-            <a:off x="3884613" y="8685213"/>
-            <a:ext cx="2971800" cy="458787"/>
-          </a:xfrm>
-          <a:prstGeom prst="rect">
-            <a:avLst/>
-          </a:prstGeom>
-        </p:spPr>
-        <p:txBody>
-          <a:bodyPr vert="horz" lIns="91440" tIns="45720" rIns="91440" bIns="45720" rtlCol="0" anchor="b"/>
-          <a:lstStyle>
-            <a:lvl1pPr algn="r">
-              <a:defRPr sz="1200"/>
-            </a:lvl1pPr>
-          </a:lstStyle>
-          <a:p>
-            <a:fld id="{CE5E9CC1-C706-0F49-92D6-E571CC5EEA8F}" type="slidenum">
-              <a:rPr lang="en-US"/>
-              <a:t>‹#›</a:t>
-            </a:fld>
-            <a:endParaRPr lang="en-US"/>
-          </a:p>
-        </p:txBody>
-      </p:sp>
     </p:spTree>
     <p:extLst>
       <p:ext uri="{BB962C8B-B14F-4D97-AF65-F5344CB8AC3E}">
-        <p14:creationId xmlns:p14="http://schemas.microsoft.com/office/powerpoint/2010/main" val="1024086991"/>
+        <p14:creationId xmlns:p14="http://schemas.microsoft.com/office/powerpoint/2010/main" val="1626605445"/>
       </p:ext>
     </p:extLst>
   </p:cSld>
@@ -503,10 +284,6 @@
           <a:bodyPr/>
           <a:lstStyle/>
           <a:p>
-            <a:r>
-              <a:rPr lang="en-US" dirty="0"/>
-              <a:t/>
-            </a:r>
             <a:endParaRPr lang="en-US" dirty="0"/>
           </a:p>
         </p:txBody>
@@ -591,10 +368,6 @@
           <a:bodyPr/>
           <a:lstStyle/>
           <a:p>
-            <a:r>
-              <a:rPr lang="en-US" dirty="0"/>
-              <a:t/>
-            </a:r>
             <a:endParaRPr lang="en-US" dirty="0"/>
           </a:p>
         </p:txBody>
@@ -679,10 +452,6 @@
           <a:bodyPr/>
           <a:lstStyle/>
           <a:p>
-            <a:r>
-              <a:rPr lang="en-US" dirty="0"/>
-              <a:t/>
-            </a:r>
             <a:endParaRPr lang="en-US" dirty="0"/>
           </a:p>
         </p:txBody>
@@ -767,10 +536,6 @@
           <a:bodyPr/>
           <a:lstStyle/>
           <a:p>
-            <a:r>
-              <a:rPr lang="en-US" dirty="0"/>
-              <a:t/>
-            </a:r>
             <a:endParaRPr lang="en-US" dirty="0"/>
           </a:p>
         </p:txBody>
@@ -844,6 +609,11 @@
 <file path=ppt/slideMasters/slideMaster1.xml><?xml version="1.0" encoding="utf-8"?>
 <p:sldMaster xmlns:a="http://schemas.openxmlformats.org/drawingml/2006/main" xmlns:r="http://schemas.openxmlformats.org/officeDocument/2006/relationships" xmlns:p="http://schemas.openxmlformats.org/presentationml/2006/main">
   <p:cSld>
+    <p:bg>
+      <p:bgRef idx="1001">
+        <a:schemeClr val="bg1"/>
+      </p:bgRef>
+    </p:bg>
     <p:spTree>
       <p:nvGrpSpPr>
         <p:cNvPr id="1" name=""/>
@@ -1124,8 +894,9 @@
     <p:bg>
       <p:bgPr>
         <a:solidFill>
-          <a:srgbClr val="131F16"/>
+          <a:srgbClr val="111111"/>
         </a:solidFill>
+        <a:effectLst/>
       </p:bgPr>
     </p:bg>
     <p:spTree>
@@ -1144,22 +915,22 @@
       </p:grpSpPr>
       <p:pic>
         <p:nvPicPr>
-          <p:cNvPr id="2" name="Image 0" descr="preencoded.png">    </p:cNvPr>
+          <p:cNvPr id="3" name="Image 1" descr="preencoded.png"/>
           <p:cNvPicPr>
             <a:picLocks noChangeAspect="1"/>
           </p:cNvPicPr>
           <p:nvPr/>
         </p:nvPicPr>
         <p:blipFill>
-          <a:blip r:embed="rId1"/>
+          <a:blip r:embed="rId3"/>
           <a:stretch>
             <a:fillRect/>
           </a:stretch>
         </p:blipFill>
         <p:spPr>
           <a:xfrm>
-            <a:off x="6446520" y="0"/>
-            <a:ext cx="2697480" cy="2697480"/>
+            <a:off x="-365760" y="3291840"/>
+            <a:ext cx="2560320" cy="2560320"/>
           </a:xfrm>
           <a:prstGeom prst="rect">
             <a:avLst/>
@@ -1168,22 +939,22 @@
       </p:pic>
       <p:pic>
         <p:nvPicPr>
-          <p:cNvPr id="3" name="Image 1" descr="preencoded.png">    </p:cNvPr>
+          <p:cNvPr id="4" name="Image 2" descr="preencoded.png"/>
           <p:cNvPicPr>
             <a:picLocks noChangeAspect="1"/>
           </p:cNvPicPr>
           <p:nvPr/>
         </p:nvPicPr>
         <p:blipFill>
-          <a:blip r:embed="rId2"/>
+          <a:blip r:embed="rId4"/>
           <a:stretch>
             <a:fillRect/>
           </a:stretch>
         </p:blipFill>
         <p:spPr>
           <a:xfrm>
-            <a:off x="0" y="3314700"/>
-            <a:ext cx="1828800" cy="1828800"/>
+            <a:off x="0" y="0"/>
+            <a:ext cx="9144000" cy="5143500"/>
           </a:xfrm>
           <a:prstGeom prst="rect">
             <a:avLst/>
@@ -1192,39 +963,14 @@
       </p:pic>
       <p:sp>
         <p:nvSpPr>
-          <p:cNvPr id="4" name="Shape 0"/>
-          <p:cNvSpPr/>
-          <p:nvPr/>
-        </p:nvSpPr>
-        <p:spPr>
-          <a:xfrm>
-            <a:off x="0" y="0"/>
-            <a:ext cx="256032" cy="5143500"/>
-          </a:xfrm>
-          <a:prstGeom prst="rect">
-            <a:avLst/>
-          </a:prstGeom>
-          <a:solidFill>
-            <a:srgbClr val="2D5A3D"/>
-          </a:solidFill>
-          <a:ln w="12700">
-            <a:solidFill>
-              <a:srgbClr val="2D5A3D"/>
-            </a:solidFill>
-            <a:prstDash val="solid"/>
-          </a:ln>
-        </p:spPr>
-      </p:sp>
-      <p:sp>
-        <p:nvSpPr>
-          <p:cNvPr id="5" name="Text 1"/>
-          <p:cNvSpPr/>
-          <p:nvPr/>
-        </p:nvSpPr>
-        <p:spPr>
-          <a:xfrm>
-            <a:off x="502920" y="1005840"/>
-            <a:ext cx="6583680" cy="1051560"/>
+          <p:cNvPr id="5" name="Text 0"/>
+          <p:cNvSpPr/>
+          <p:nvPr/>
+        </p:nvSpPr>
+        <p:spPr>
+          <a:xfrm rot="16200000">
+            <a:off x="-1097280" y="1938528"/>
+            <a:ext cx="2514600" cy="329184"/>
           </a:xfrm>
           <a:prstGeom prst="rect">
             <a:avLst/>
@@ -1236,34 +982,73 @@
           <a:bodyPr wrap="square" lIns="0" tIns="0" rIns="0" bIns="0" rtlCol="0" anchor="ctr"/>
           <a:lstStyle/>
           <a:p>
-            <a:pPr algn="l" indent="0" marL="0">
+            <a:pPr marL="0" indent="0" algn="ctr">
               <a:buNone/>
             </a:pPr>
             <a:r>
-              <a:rPr lang="en-US" sz="5600" b="1" spc="300" kern="0" dirty="0">
+              <a:rPr lang="en-US" sz="900" b="1" kern="0" spc="600" dirty="0">
+                <a:solidFill>
+                  <a:srgbClr val="C8910A"/>
+                </a:solidFill>
+                <a:latin typeface="Century Gothic" pitchFamily="34" charset="0"/>
+                <a:ea typeface="Century Gothic" pitchFamily="34" charset="-122"/>
+                <a:cs typeface="Century Gothic" pitchFamily="34" charset="-120"/>
+              </a:rPr>
+              <a:t>AI IN REACH</a:t>
+            </a:r>
+            <a:endParaRPr lang="en-US" sz="900" dirty="0"/>
+          </a:p>
+        </p:txBody>
+      </p:sp>
+      <p:sp>
+        <p:nvSpPr>
+          <p:cNvPr id="6" name="Text 1"/>
+          <p:cNvSpPr/>
+          <p:nvPr/>
+        </p:nvSpPr>
+        <p:spPr>
+          <a:xfrm>
+            <a:off x="475488" y="960120"/>
+            <a:ext cx="5486400" cy="1051560"/>
+          </a:xfrm>
+          <a:prstGeom prst="rect">
+            <a:avLst/>
+          </a:prstGeom>
+          <a:noFill/>
+          <a:ln/>
+        </p:spPr>
+        <p:txBody>
+          <a:bodyPr wrap="square" lIns="0" tIns="0" rIns="0" bIns="0" rtlCol="0" anchor="ctr"/>
+          <a:lstStyle/>
+          <a:p>
+            <a:pPr marL="0" indent="0" algn="l">
+              <a:buNone/>
+            </a:pPr>
+            <a:r>
+              <a:rPr lang="en-US" sz="6600" b="1" kern="0" spc="100" dirty="0">
                 <a:solidFill>
                   <a:srgbClr val="FFFFFF"/>
                 </a:solidFill>
-                <a:latin typeface="Calibri" pitchFamily="34" charset="0"/>
-                <a:ea typeface="Calibri" pitchFamily="34" charset="-122"/>
-                <a:cs typeface="Calibri" pitchFamily="34" charset="-120"/>
+                <a:latin typeface="Century Gothic" pitchFamily="34" charset="0"/>
+                <a:ea typeface="Century Gothic" pitchFamily="34" charset="-122"/>
+                <a:cs typeface="Century Gothic" pitchFamily="34" charset="-120"/>
               </a:rPr>
               <a:t>PROJECT AIR</a:t>
             </a:r>
-            <a:endParaRPr lang="en-US" sz="5600" dirty="0"/>
-          </a:p>
-        </p:txBody>
-      </p:sp>
-      <p:sp>
-        <p:nvSpPr>
-          <p:cNvPr id="6" name="Text 2"/>
-          <p:cNvSpPr/>
-          <p:nvPr/>
-        </p:nvSpPr>
-        <p:spPr>
-          <a:xfrm>
-            <a:off x="502920" y="2148840"/>
-            <a:ext cx="6583680" cy="457200"/>
+            <a:endParaRPr lang="en-US" sz="6600" dirty="0"/>
+          </a:p>
+        </p:txBody>
+      </p:sp>
+      <p:sp>
+        <p:nvSpPr>
+          <p:cNvPr id="7" name="Text 2"/>
+          <p:cNvSpPr/>
+          <p:nvPr/>
+        </p:nvSpPr>
+        <p:spPr>
+          <a:xfrm>
+            <a:off x="475488" y="2157984"/>
+            <a:ext cx="5029200" cy="402336"/>
           </a:xfrm>
           <a:prstGeom prst="rect">
             <a:avLst/>
@@ -1275,57 +1060,34 @@
           <a:bodyPr wrap="square" lIns="0" tIns="0" rIns="0" bIns="0" rtlCol="0" anchor="ctr"/>
           <a:lstStyle/>
           <a:p>
-            <a:pPr algn="l" indent="0" marL="0">
+            <a:pPr marL="0" indent="0" algn="l">
               <a:buNone/>
             </a:pPr>
             <a:r>
-              <a:rPr lang="en-US" sz="2000" spc="500" kern="0" dirty="0">
+              <a:rPr lang="en-US" sz="1500" kern="0" spc="800" dirty="0">
                 <a:solidFill>
-                  <a:srgbClr val="9DC08B"/>
+                  <a:srgbClr val="C8910A"/>
                 </a:solidFill>
-                <a:latin typeface="Calibri" pitchFamily="34" charset="0"/>
-                <a:ea typeface="Calibri" pitchFamily="34" charset="-122"/>
-                <a:cs typeface="Calibri" pitchFamily="34" charset="-120"/>
+                <a:latin typeface="Century Gothic" pitchFamily="34" charset="0"/>
+                <a:ea typeface="Century Gothic" pitchFamily="34" charset="-122"/>
+                <a:cs typeface="Century Gothic" pitchFamily="34" charset="-120"/>
               </a:rPr>
               <a:t>LOGO DIRECTION</a:t>
             </a:r>
-            <a:endParaRPr lang="en-US" sz="2000" dirty="0"/>
-          </a:p>
-        </p:txBody>
-      </p:sp>
-      <p:sp>
-        <p:nvSpPr>
-          <p:cNvPr id="7" name="Shape 3"/>
-          <p:cNvSpPr/>
-          <p:nvPr/>
-        </p:nvSpPr>
-        <p:spPr>
-          <a:xfrm>
-            <a:off x="502920" y="2743200"/>
-            <a:ext cx="2560320" cy="0"/>
-          </a:xfrm>
-          <a:prstGeom prst="line">
-            <a:avLst/>
-          </a:prstGeom>
-          <a:noFill/>
-          <a:ln w="19050">
-            <a:solidFill>
-              <a:srgbClr val="4A7C59"/>
-            </a:solidFill>
-            <a:prstDash val="solid"/>
-          </a:ln>
-        </p:spPr>
-      </p:sp>
-      <p:sp>
-        <p:nvSpPr>
-          <p:cNvPr id="8" name="Text 4"/>
-          <p:cNvSpPr/>
-          <p:nvPr/>
-        </p:nvSpPr>
-        <p:spPr>
-          <a:xfrm>
-            <a:off x="502920" y="2907792"/>
-            <a:ext cx="6217920" cy="1737360"/>
+            <a:endParaRPr lang="en-US" sz="1500" dirty="0"/>
+          </a:p>
+        </p:txBody>
+      </p:sp>
+      <p:sp>
+        <p:nvSpPr>
+          <p:cNvPr id="8" name="Text 3"/>
+          <p:cNvSpPr/>
+          <p:nvPr/>
+        </p:nvSpPr>
+        <p:spPr>
+          <a:xfrm>
+            <a:off x="475488" y="2651760"/>
+            <a:ext cx="5303520" cy="310896"/>
           </a:xfrm>
           <a:prstGeom prst="rect">
             <a:avLst/>
@@ -1334,30 +1096,105 @@
           <a:ln/>
         </p:spPr>
         <p:txBody>
+          <a:bodyPr wrap="square" lIns="0" tIns="0" rIns="0" bIns="0" rtlCol="0" anchor="ctr"/>
+          <a:lstStyle/>
+          <a:p>
+            <a:pPr marL="0" indent="0" algn="l">
+              <a:buNone/>
+            </a:pPr>
+            <a:r>
+              <a:rPr lang="en-US" sz="1000" kern="0" spc="50" dirty="0">
+                <a:solidFill>
+                  <a:srgbClr val="555555"/>
+                </a:solidFill>
+                <a:latin typeface="IBM Plex Sans" pitchFamily="34" charset="0"/>
+                <a:ea typeface="IBM Plex Sans" pitchFamily="34" charset="-122"/>
+                <a:cs typeface="IBM Plex Sans" pitchFamily="34" charset="-120"/>
+              </a:rPr>
+              <a:t>AI in Reach  |  The Weather Company  |  AI Day, June 9, 2026</a:t>
+            </a:r>
+            <a:endParaRPr lang="en-US" sz="1000" dirty="0"/>
+          </a:p>
+        </p:txBody>
+      </p:sp>
+      <p:sp>
+        <p:nvSpPr>
+          <p:cNvPr id="9" name="Text 4"/>
+          <p:cNvSpPr/>
+          <p:nvPr/>
+        </p:nvSpPr>
+        <p:spPr>
+          <a:xfrm>
+            <a:off x="475488" y="3090672"/>
+            <a:ext cx="5029200" cy="1828800"/>
+          </a:xfrm>
+          <a:prstGeom prst="rect">
+            <a:avLst/>
+          </a:prstGeom>
+          <a:noFill/>
+          <a:ln/>
+        </p:spPr>
+        <p:txBody>
           <a:bodyPr wrap="square" lIns="0" tIns="0" rIns="0" bIns="0" rtlCol="0" anchor="t"/>
           <a:lstStyle/>
           <a:p>
-            <a:pPr algn="l" indent="0" marL="0">
+            <a:pPr marL="0" indent="0" algn="l">
               <a:lnSpc>
-                <a:spcPct val="140000"/>
+                <a:spcPct val="145000"/>
               </a:lnSpc>
               <a:buNone/>
             </a:pPr>
             <a:r>
-              <a:rPr lang="en-US" sz="1250" dirty="0">
+              <a:rPr lang="en-US" sz="1200" dirty="0">
                 <a:solidFill>
-                  <a:srgbClr val="C5D5BB"/>
+                  <a:srgbClr val="777777"/>
                 </a:solidFill>
-                <a:latin typeface="Calibri" pitchFamily="34" charset="0"/>
-                <a:ea typeface="Calibri" pitchFamily="34" charset="-122"/>
-                <a:cs typeface="Calibri" pitchFamily="34" charset="-120"/>
+                <a:latin typeface="IBM Plex Sans" pitchFamily="34" charset="0"/>
+                <a:ea typeface="IBM Plex Sans" pitchFamily="34" charset="-122"/>
+                <a:cs typeface="IBM Plex Sans" pitchFamily="34" charset="-120"/>
               </a:rPr>
-              <a:t>This presentation shows the logo concept(s) for Project AIR: AI in Reach. The logo is the foundation — once approved, it unlocks every other deliverable: the poster system, badge and lanyard design, the PowerPoint template, and swag. Feedback here moves the whole project forward.</a:t>
+              <a:t>This presentation shows the logo concept(s) for Project AIR: AI in Reach. The logo is the foundation - once approved, it unlocks every other deliverable: the poster system, badge and lanyard design, the PowerPoint template, and swag. Feedback here moves the whole project forward.</a:t>
             </a:r>
-            <a:endParaRPr lang="en-US" sz="1250" dirty="0"/>
-          </a:p>
-        </p:txBody>
-      </p:sp>
+            <a:endParaRPr lang="en-US" sz="1200" dirty="0"/>
+          </a:p>
+        </p:txBody>
+      </p:sp>
+      <p:pic>
+        <p:nvPicPr>
+          <p:cNvPr id="10" name="Graphic 9">
+            <a:extLst>
+              <a:ext uri="{FF2B5EF4-FFF2-40B4-BE49-F238E27FC236}">
+                <a16:creationId xmlns:a16="http://schemas.microsoft.com/office/drawing/2014/main" id="{8D1C3EB5-34C5-B622-BAB4-39DC08493231}"/>
+              </a:ext>
+            </a:extLst>
+          </p:cNvPr>
+          <p:cNvPicPr>
+            <a:picLocks noChangeAspect="1"/>
+          </p:cNvPicPr>
+          <p:nvPr/>
+        </p:nvPicPr>
+        <p:blipFill>
+          <a:blip r:embed="rId5">
+            <a:extLst>
+              <a:ext uri="{96DAC541-7B7A-43D3-8B79-37D633B846F1}">
+                <asvg:svgBlip xmlns:asvg="http://schemas.microsoft.com/office/drawing/2016/SVG/main" r:embed="rId5"/>
+              </a:ext>
+            </a:extLst>
+          </a:blip>
+          <a:stretch>
+            <a:fillRect/>
+          </a:stretch>
+        </p:blipFill>
+        <p:spPr>
+          <a:xfrm>
+            <a:off x="7132712" y="3995928"/>
+            <a:ext cx="2020432" cy="1137018"/>
+          </a:xfrm>
+          <a:prstGeom prst="rect">
+            <a:avLst/>
+          </a:prstGeom>
+        </p:spPr>
+      </p:pic>
     </p:spTree>
   </p:cSld>
   <p:clrMapOvr>
@@ -1372,8 +1209,9 @@
     <p:bg>
       <p:bgPr>
         <a:solidFill>
-          <a:srgbClr val="F5F4F0"/>
+          <a:srgbClr val="EDEBE4"/>
         </a:solidFill>
+        <a:effectLst/>
       </p:bgPr>
     </p:bg>
     <p:spTree>
@@ -1392,63 +1230,126 @@
       </p:grpSpPr>
       <p:pic>
         <p:nvPicPr>
-          <p:cNvPr id="2" name="Image 0" descr="preencoded.png">    </p:cNvPr>
+          <p:cNvPr id="2" name="Image 0" descr="preencoded.png"/>
           <p:cNvPicPr>
             <a:picLocks noChangeAspect="1"/>
           </p:cNvPicPr>
           <p:nvPr/>
         </p:nvPicPr>
         <p:blipFill>
-          <a:blip r:embed="rId1"/>
+          <a:blip r:embed="rId3"/>
           <a:stretch>
             <a:fillRect/>
           </a:stretch>
         </p:blipFill>
         <p:spPr>
           <a:xfrm>
-            <a:off x="6903720" y="0"/>
-            <a:ext cx="2240280" cy="2240280"/>
+            <a:off x="91440" y="1188720"/>
+            <a:ext cx="9144000" cy="5143500"/>
           </a:xfrm>
           <a:prstGeom prst="rect">
             <a:avLst/>
           </a:prstGeom>
         </p:spPr>
       </p:pic>
-      <p:sp>
-        <p:nvSpPr>
-          <p:cNvPr id="3" name="Shape 0"/>
+      <p:pic>
+        <p:nvPicPr>
+          <p:cNvPr id="3" name="Image 1" descr="preencoded.png"/>
+          <p:cNvPicPr>
+            <a:picLocks noChangeAspect="1"/>
+          </p:cNvPicPr>
+          <p:nvPr/>
+        </p:nvPicPr>
+        <p:blipFill>
+          <a:blip r:embed="rId4"/>
+          <a:stretch>
+            <a:fillRect/>
+          </a:stretch>
+        </p:blipFill>
+        <p:spPr>
+          <a:xfrm>
+            <a:off x="7680960" y="0"/>
+            <a:ext cx="1463040" cy="1463040"/>
+          </a:xfrm>
+          <a:prstGeom prst="rect">
+            <a:avLst/>
+          </a:prstGeom>
+        </p:spPr>
+      </p:pic>
+      <p:sp>
+        <p:nvSpPr>
+          <p:cNvPr id="5" name="Shape 0"/>
           <p:cNvSpPr/>
           <p:nvPr/>
         </p:nvSpPr>
         <p:spPr>
           <a:xfrm>
             <a:off x="0" y="0"/>
-            <a:ext cx="9144000" cy="594360"/>
-          </a:xfrm>
-          <a:prstGeom prst="rect">
-            <a:avLst/>
-          </a:prstGeom>
-          <a:solidFill>
-            <a:srgbClr val="1B3A2D"/>
+            <a:ext cx="9144000" cy="548640"/>
+          </a:xfrm>
+          <a:prstGeom prst="rect">
+            <a:avLst/>
+          </a:prstGeom>
+          <a:solidFill>
+            <a:srgbClr val="111111"/>
           </a:solidFill>
           <a:ln w="12700">
             <a:solidFill>
-              <a:srgbClr val="1B3A2D"/>
+              <a:srgbClr val="111111"/>
             </a:solidFill>
             <a:prstDash val="solid"/>
           </a:ln>
         </p:spPr>
-      </p:sp>
-      <p:sp>
-        <p:nvSpPr>
-          <p:cNvPr id="4" name="Text 1"/>
-          <p:cNvSpPr/>
-          <p:nvPr/>
-        </p:nvSpPr>
-        <p:spPr>
-          <a:xfrm>
-            <a:off x="320040" y="0"/>
-            <a:ext cx="5029200" cy="594360"/>
+        <p:txBody>
+          <a:bodyPr/>
+          <a:lstStyle/>
+          <a:p>
+            <a:endParaRPr lang="en-US" dirty="0"/>
+          </a:p>
+        </p:txBody>
+      </p:sp>
+      <p:sp>
+        <p:nvSpPr>
+          <p:cNvPr id="6" name="Shape 1"/>
+          <p:cNvSpPr/>
+          <p:nvPr/>
+        </p:nvSpPr>
+        <p:spPr>
+          <a:xfrm>
+            <a:off x="164592" y="219456"/>
+            <a:ext cx="109728" cy="109728"/>
+          </a:xfrm>
+          <a:prstGeom prst="ellipse">
+            <a:avLst/>
+          </a:prstGeom>
+          <a:solidFill>
+            <a:srgbClr val="C8910A"/>
+          </a:solidFill>
+          <a:ln w="12700">
+            <a:solidFill>
+              <a:srgbClr val="C8910A"/>
+            </a:solidFill>
+            <a:prstDash val="solid"/>
+          </a:ln>
+        </p:spPr>
+        <p:txBody>
+          <a:bodyPr/>
+          <a:lstStyle/>
+          <a:p>
+            <a:endParaRPr lang="en-US"/>
+          </a:p>
+        </p:txBody>
+      </p:sp>
+      <p:sp>
+        <p:nvSpPr>
+          <p:cNvPr id="7" name="Text 2"/>
+          <p:cNvSpPr/>
+          <p:nvPr/>
+        </p:nvSpPr>
+        <p:spPr>
+          <a:xfrm>
+            <a:off x="365760" y="0"/>
+            <a:ext cx="5029200" cy="548640"/>
           </a:xfrm>
           <a:prstGeom prst="rect">
             <a:avLst/>
@@ -1460,34 +1361,34 @@
           <a:bodyPr wrap="square" lIns="0" tIns="0" rIns="0" bIns="0" rtlCol="0" anchor="ctr"/>
           <a:lstStyle/>
           <a:p>
-            <a:pPr algn="l" indent="0" marL="0">
+            <a:pPr marL="0" indent="0" algn="l">
               <a:buNone/>
             </a:pPr>
             <a:r>
-              <a:rPr lang="en-US" sz="2100" b="1" spc="100" kern="0" dirty="0">
+              <a:rPr lang="en-US" sz="1900" b="1" kern="0" spc="100" dirty="0">
                 <a:solidFill>
                   <a:srgbClr val="FFFFFF"/>
                 </a:solidFill>
-                <a:latin typeface="Calibri" pitchFamily="34" charset="0"/>
-                <a:ea typeface="Calibri" pitchFamily="34" charset="-122"/>
-                <a:cs typeface="Calibri" pitchFamily="34" charset="-120"/>
+                <a:latin typeface="Century Gothic" pitchFamily="34" charset="0"/>
+                <a:ea typeface="Century Gothic" pitchFamily="34" charset="-122"/>
+                <a:cs typeface="Century Gothic" pitchFamily="34" charset="-120"/>
               </a:rPr>
               <a:t>Concept A</a:t>
             </a:r>
-            <a:endParaRPr lang="en-US" sz="2100" dirty="0"/>
-          </a:p>
-        </p:txBody>
-      </p:sp>
-      <p:sp>
-        <p:nvSpPr>
-          <p:cNvPr id="5" name="Shape 2"/>
-          <p:cNvSpPr/>
-          <p:nvPr/>
-        </p:nvSpPr>
-        <p:spPr>
-          <a:xfrm>
-            <a:off x="0" y="594360"/>
-            <a:ext cx="4434840" cy="2274570"/>
+            <a:endParaRPr lang="en-US" sz="1900" dirty="0"/>
+          </a:p>
+        </p:txBody>
+      </p:sp>
+      <p:sp>
+        <p:nvSpPr>
+          <p:cNvPr id="8" name="Shape 3"/>
+          <p:cNvSpPr/>
+          <p:nvPr/>
+        </p:nvSpPr>
+        <p:spPr>
+          <a:xfrm>
+            <a:off x="0" y="548640"/>
+            <a:ext cx="4251960" cy="2297430"/>
           </a:xfrm>
           <a:prstGeom prst="rect">
             <a:avLst/>
@@ -1497,22 +1398,29 @@
           </a:solidFill>
           <a:ln w="6350">
             <a:solidFill>
-              <a:srgbClr val="E8E3DD"/>
+              <a:srgbClr val="DDD8D2"/>
             </a:solidFill>
             <a:prstDash val="solid"/>
           </a:ln>
         </p:spPr>
-      </p:sp>
-      <p:sp>
-        <p:nvSpPr>
-          <p:cNvPr id="6" name="Text 3"/>
-          <p:cNvSpPr/>
-          <p:nvPr/>
-        </p:nvSpPr>
-        <p:spPr>
-          <a:xfrm>
-            <a:off x="91440" y="685800"/>
-            <a:ext cx="4251960" cy="256032"/>
+        <p:txBody>
+          <a:bodyPr/>
+          <a:lstStyle/>
+          <a:p>
+            <a:endParaRPr lang="en-US"/>
+          </a:p>
+        </p:txBody>
+      </p:sp>
+      <p:sp>
+        <p:nvSpPr>
+          <p:cNvPr id="9" name="Text 4"/>
+          <p:cNvSpPr/>
+          <p:nvPr/>
+        </p:nvSpPr>
+        <p:spPr>
+          <a:xfrm>
+            <a:off x="91440" y="640080"/>
+            <a:ext cx="4069080" cy="219456"/>
           </a:xfrm>
           <a:prstGeom prst="rect">
             <a:avLst/>
@@ -1524,17 +1432,17 @@
           <a:bodyPr wrap="square" lIns="0" tIns="0" rIns="0" bIns="0" rtlCol="0" anchor="ctr"/>
           <a:lstStyle/>
           <a:p>
-            <a:pPr algn="ctr" indent="0" marL="0">
+            <a:pPr marL="0" indent="0" algn="ctr">
               <a:buNone/>
             </a:pPr>
             <a:r>
-              <a:rPr lang="en-US" sz="700" spc="300" kern="0" dirty="0">
+              <a:rPr lang="en-US" sz="700" kern="0" spc="300" dirty="0">
                 <a:solidFill>
                   <a:srgbClr val="AAAAAA"/>
                 </a:solidFill>
-                <a:latin typeface="Calibri" pitchFamily="34" charset="0"/>
-                <a:ea typeface="Calibri" pitchFamily="34" charset="-122"/>
-                <a:cs typeface="Calibri" pitchFamily="34" charset="-120"/>
+                <a:latin typeface="IBM Plex Sans" pitchFamily="34" charset="0"/>
+                <a:ea typeface="IBM Plex Sans" pitchFamily="34" charset="-122"/>
+                <a:cs typeface="IBM Plex Sans" pitchFamily="34" charset="-120"/>
               </a:rPr>
               <a:t>LIGHT BACKGROUND</a:t>
             </a:r>
@@ -1544,14 +1452,14 @@
       </p:sp>
       <p:sp>
         <p:nvSpPr>
-          <p:cNvPr id="7" name="Shape 4"/>
-          <p:cNvSpPr/>
-          <p:nvPr/>
-        </p:nvSpPr>
-        <p:spPr>
-          <a:xfrm>
-            <a:off x="960120" y="1228725"/>
-            <a:ext cx="2514600" cy="1188720"/>
+          <p:cNvPr id="10" name="Shape 5"/>
+          <p:cNvSpPr/>
+          <p:nvPr/>
+        </p:nvSpPr>
+        <p:spPr>
+          <a:xfrm>
+            <a:off x="914400" y="1231011"/>
+            <a:ext cx="2423160" cy="1078992"/>
           </a:xfrm>
           <a:prstGeom prst="rect">
             <a:avLst/>
@@ -1566,17 +1474,24 @@
             <a:prstDash val="dash"/>
           </a:ln>
         </p:spPr>
-      </p:sp>
-      <p:sp>
-        <p:nvSpPr>
-          <p:cNvPr id="8" name="Text 5"/>
-          <p:cNvSpPr/>
-          <p:nvPr/>
-        </p:nvSpPr>
-        <p:spPr>
-          <a:xfrm>
-            <a:off x="960120" y="1228725"/>
-            <a:ext cx="2514600" cy="1188720"/>
+        <p:txBody>
+          <a:bodyPr/>
+          <a:lstStyle/>
+          <a:p>
+            <a:endParaRPr lang="en-US"/>
+          </a:p>
+        </p:txBody>
+      </p:sp>
+      <p:sp>
+        <p:nvSpPr>
+          <p:cNvPr id="11" name="Text 6"/>
+          <p:cNvSpPr/>
+          <p:nvPr/>
+        </p:nvSpPr>
+        <p:spPr>
+          <a:xfrm>
+            <a:off x="914400" y="1231011"/>
+            <a:ext cx="2423160" cy="1078992"/>
           </a:xfrm>
           <a:prstGeom prst="rect">
             <a:avLst/>
@@ -1588,7 +1503,7 @@
           <a:bodyPr wrap="square" lIns="0" tIns="0" rIns="0" bIns="0" rtlCol="0" anchor="ctr"/>
           <a:lstStyle/>
           <a:p>
-            <a:pPr algn="ctr" indent="0" marL="0">
+            <a:pPr marL="0" indent="0" algn="ctr">
               <a:buNone/>
             </a:pPr>
             <a:r>
@@ -1596,11 +1511,11 @@
                 <a:solidFill>
                   <a:srgbClr val="AAAAAA"/>
                 </a:solidFill>
-                <a:latin typeface="Calibri" pitchFamily="34" charset="0"/>
-                <a:ea typeface="Calibri" pitchFamily="34" charset="-122"/>
-                <a:cs typeface="Calibri" pitchFamily="34" charset="-120"/>
+                <a:latin typeface="IBM Plex Sans" pitchFamily="34" charset="0"/>
+                <a:ea typeface="IBM Plex Sans" pitchFamily="34" charset="-122"/>
+                <a:cs typeface="IBM Plex Sans" pitchFamily="34" charset="-120"/>
               </a:rPr>
-              <a:t>Logo — Light Background</a:t>
+              <a:t>Logo - Light Background</a:t>
             </a:r>
             <a:endParaRPr lang="en-US" sz="1000" dirty="0"/>
           </a:p>
@@ -1608,39 +1523,46 @@
       </p:sp>
       <p:sp>
         <p:nvSpPr>
-          <p:cNvPr id="9" name="Shape 6"/>
-          <p:cNvSpPr/>
-          <p:nvPr/>
-        </p:nvSpPr>
-        <p:spPr>
-          <a:xfrm>
-            <a:off x="0" y="2868930"/>
-            <a:ext cx="4434840" cy="2274570"/>
-          </a:xfrm>
-          <a:prstGeom prst="rect">
-            <a:avLst/>
-          </a:prstGeom>
-          <a:solidFill>
-            <a:srgbClr val="1A1A1A"/>
+          <p:cNvPr id="12" name="Shape 7"/>
+          <p:cNvSpPr/>
+          <p:nvPr/>
+        </p:nvSpPr>
+        <p:spPr>
+          <a:xfrm>
+            <a:off x="0" y="2846070"/>
+            <a:ext cx="4251960" cy="2297430"/>
+          </a:xfrm>
+          <a:prstGeom prst="rect">
+            <a:avLst/>
+          </a:prstGeom>
+          <a:solidFill>
+            <a:srgbClr val="111111"/>
           </a:solidFill>
           <a:ln w="12700">
             <a:solidFill>
-              <a:srgbClr val="1A1A1A"/>
+              <a:srgbClr val="111111"/>
             </a:solidFill>
             <a:prstDash val="solid"/>
           </a:ln>
         </p:spPr>
-      </p:sp>
-      <p:sp>
-        <p:nvSpPr>
-          <p:cNvPr id="10" name="Text 7"/>
-          <p:cNvSpPr/>
-          <p:nvPr/>
-        </p:nvSpPr>
-        <p:spPr>
-          <a:xfrm>
-            <a:off x="91440" y="2960370"/>
-            <a:ext cx="4251960" cy="256032"/>
+        <p:txBody>
+          <a:bodyPr/>
+          <a:lstStyle/>
+          <a:p>
+            <a:endParaRPr lang="en-US"/>
+          </a:p>
+        </p:txBody>
+      </p:sp>
+      <p:sp>
+        <p:nvSpPr>
+          <p:cNvPr id="13" name="Text 8"/>
+          <p:cNvSpPr/>
+          <p:nvPr/>
+        </p:nvSpPr>
+        <p:spPr>
+          <a:xfrm>
+            <a:off x="91440" y="2937510"/>
+            <a:ext cx="4069080" cy="219456"/>
           </a:xfrm>
           <a:prstGeom prst="rect">
             <a:avLst/>
@@ -1652,17 +1574,17 @@
           <a:bodyPr wrap="square" lIns="0" tIns="0" rIns="0" bIns="0" rtlCol="0" anchor="ctr"/>
           <a:lstStyle/>
           <a:p>
-            <a:pPr algn="ctr" indent="0" marL="0">
+            <a:pPr marL="0" indent="0" algn="ctr">
               <a:buNone/>
             </a:pPr>
             <a:r>
-              <a:rPr lang="en-US" sz="700" spc="300" kern="0" dirty="0">
+              <a:rPr lang="en-US" sz="700" kern="0" spc="300" dirty="0">
                 <a:solidFill>
-                  <a:srgbClr val="666666"/>
+                  <a:srgbClr val="494949"/>
                 </a:solidFill>
-                <a:latin typeface="Calibri" pitchFamily="34" charset="0"/>
-                <a:ea typeface="Calibri" pitchFamily="34" charset="-122"/>
-                <a:cs typeface="Calibri" pitchFamily="34" charset="-120"/>
+                <a:latin typeface="IBM Plex Sans" pitchFamily="34" charset="0"/>
+                <a:ea typeface="IBM Plex Sans" pitchFamily="34" charset="-122"/>
+                <a:cs typeface="IBM Plex Sans" pitchFamily="34" charset="-120"/>
               </a:rPr>
               <a:t>DARK BACKGROUND</a:t>
             </a:r>
@@ -1672,39 +1594,46 @@
       </p:sp>
       <p:sp>
         <p:nvSpPr>
-          <p:cNvPr id="11" name="Shape 8"/>
-          <p:cNvSpPr/>
-          <p:nvPr/>
-        </p:nvSpPr>
-        <p:spPr>
-          <a:xfrm>
-            <a:off x="960120" y="3503295"/>
-            <a:ext cx="2514600" cy="1188720"/>
-          </a:xfrm>
-          <a:prstGeom prst="rect">
-            <a:avLst/>
-          </a:prstGeom>
-          <a:solidFill>
-            <a:srgbClr val="1A1A1A"/>
+          <p:cNvPr id="14" name="Shape 9"/>
+          <p:cNvSpPr/>
+          <p:nvPr/>
+        </p:nvSpPr>
+        <p:spPr>
+          <a:xfrm>
+            <a:off x="914400" y="3528441"/>
+            <a:ext cx="2423160" cy="1078992"/>
+          </a:xfrm>
+          <a:prstGeom prst="rect">
+            <a:avLst/>
+          </a:prstGeom>
+          <a:solidFill>
+            <a:srgbClr val="111111"/>
           </a:solidFill>
           <a:ln w="9525">
             <a:solidFill>
-              <a:srgbClr val="4A4A4A"/>
+              <a:srgbClr val="3A3A3A"/>
             </a:solidFill>
             <a:prstDash val="dash"/>
           </a:ln>
         </p:spPr>
-      </p:sp>
-      <p:sp>
-        <p:nvSpPr>
-          <p:cNvPr id="12" name="Text 9"/>
-          <p:cNvSpPr/>
-          <p:nvPr/>
-        </p:nvSpPr>
-        <p:spPr>
-          <a:xfrm>
-            <a:off x="960120" y="3503295"/>
-            <a:ext cx="2514600" cy="1188720"/>
+        <p:txBody>
+          <a:bodyPr/>
+          <a:lstStyle/>
+          <a:p>
+            <a:endParaRPr lang="en-US"/>
+          </a:p>
+        </p:txBody>
+      </p:sp>
+      <p:sp>
+        <p:nvSpPr>
+          <p:cNvPr id="15" name="Text 10"/>
+          <p:cNvSpPr/>
+          <p:nvPr/>
+        </p:nvSpPr>
+        <p:spPr>
+          <a:xfrm>
+            <a:off x="914400" y="3528441"/>
+            <a:ext cx="2423160" cy="1078992"/>
           </a:xfrm>
           <a:prstGeom prst="rect">
             <a:avLst/>
@@ -1716,19 +1645,19 @@
           <a:bodyPr wrap="square" lIns="0" tIns="0" rIns="0" bIns="0" rtlCol="0" anchor="ctr"/>
           <a:lstStyle/>
           <a:p>
-            <a:pPr algn="ctr" indent="0" marL="0">
+            <a:pPr marL="0" indent="0" algn="ctr">
               <a:buNone/>
             </a:pPr>
             <a:r>
               <a:rPr lang="en-US" sz="1000" i="1" dirty="0">
                 <a:solidFill>
-                  <a:srgbClr val="666666"/>
+                  <a:srgbClr val="505050"/>
                 </a:solidFill>
-                <a:latin typeface="Calibri" pitchFamily="34" charset="0"/>
-                <a:ea typeface="Calibri" pitchFamily="34" charset="-122"/>
-                <a:cs typeface="Calibri" pitchFamily="34" charset="-120"/>
+                <a:latin typeface="IBM Plex Sans" pitchFamily="34" charset="0"/>
+                <a:ea typeface="IBM Plex Sans" pitchFamily="34" charset="-122"/>
+                <a:cs typeface="IBM Plex Sans" pitchFamily="34" charset="-120"/>
               </a:rPr>
-              <a:t>Logo — Dark Background</a:t>
+              <a:t>Logo - Dark Background</a:t>
             </a:r>
             <a:endParaRPr lang="en-US" sz="1000" dirty="0"/>
           </a:p>
@@ -1736,14 +1665,14 @@
       </p:sp>
       <p:sp>
         <p:nvSpPr>
-          <p:cNvPr id="13" name="Shape 10"/>
-          <p:cNvSpPr/>
-          <p:nvPr/>
-        </p:nvSpPr>
-        <p:spPr>
-          <a:xfrm>
-            <a:off x="4434840" y="594360"/>
-            <a:ext cx="0" cy="4549140"/>
+          <p:cNvPr id="16" name="Shape 11"/>
+          <p:cNvSpPr/>
+          <p:nvPr/>
+        </p:nvSpPr>
+        <p:spPr>
+          <a:xfrm>
+            <a:off x="4251960" y="548640"/>
+            <a:ext cx="0" cy="4594860"/>
           </a:xfrm>
           <a:prstGeom prst="line">
             <a:avLst/>
@@ -1751,22 +1680,29 @@
           <a:noFill/>
           <a:ln w="9525">
             <a:solidFill>
-              <a:srgbClr val="D0C8BF"/>
+              <a:srgbClr val="CEC9C2"/>
             </a:solidFill>
             <a:prstDash val="solid"/>
           </a:ln>
         </p:spPr>
-      </p:sp>
-      <p:sp>
-        <p:nvSpPr>
-          <p:cNvPr id="14" name="Text 11"/>
-          <p:cNvSpPr/>
-          <p:nvPr/>
-        </p:nvSpPr>
-        <p:spPr>
-          <a:xfrm>
-            <a:off x="4709160" y="841248"/>
-            <a:ext cx="4325112" cy="402336"/>
+        <p:txBody>
+          <a:bodyPr/>
+          <a:lstStyle/>
+          <a:p>
+            <a:endParaRPr lang="en-US"/>
+          </a:p>
+        </p:txBody>
+      </p:sp>
+      <p:sp>
+        <p:nvSpPr>
+          <p:cNvPr id="17" name="Text 12"/>
+          <p:cNvSpPr/>
+          <p:nvPr/>
+        </p:nvSpPr>
+        <p:spPr>
+          <a:xfrm>
+            <a:off x="4599432" y="804672"/>
+            <a:ext cx="4416552" cy="384048"/>
           </a:xfrm>
           <a:prstGeom prst="rect">
             <a:avLst/>
@@ -1778,57 +1714,66 @@
           <a:bodyPr wrap="square" lIns="0" tIns="0" rIns="0" bIns="0" rtlCol="0" anchor="ctr"/>
           <a:lstStyle/>
           <a:p>
-            <a:pPr algn="l" indent="0" marL="0">
+            <a:pPr marL="0" indent="0" algn="l">
               <a:buNone/>
             </a:pPr>
             <a:r>
-              <a:rPr lang="en-US" sz="1800" b="1" dirty="0">
+              <a:rPr lang="en-US" sz="1700" b="1" dirty="0">
                 <a:solidFill>
-                  <a:srgbClr val="1B3A2D"/>
+                  <a:srgbClr val="111111"/>
                 </a:solidFill>
-                <a:latin typeface="Calibri" pitchFamily="34" charset="0"/>
-                <a:ea typeface="Calibri" pitchFamily="34" charset="-122"/>
-                <a:cs typeface="Calibri" pitchFamily="34" charset="-120"/>
+                <a:latin typeface="Century Gothic" pitchFamily="34" charset="0"/>
+                <a:ea typeface="Century Gothic" pitchFamily="34" charset="-122"/>
+                <a:cs typeface="Century Gothic" pitchFamily="34" charset="-120"/>
               </a:rPr>
               <a:t>Rationale</a:t>
             </a:r>
-            <a:endParaRPr lang="en-US" sz="1800" dirty="0"/>
-          </a:p>
-        </p:txBody>
-      </p:sp>
-      <p:sp>
-        <p:nvSpPr>
-          <p:cNvPr id="15" name="Shape 12"/>
-          <p:cNvSpPr/>
-          <p:nvPr/>
-        </p:nvSpPr>
-        <p:spPr>
-          <a:xfrm>
-            <a:off x="4709160" y="1307592"/>
-            <a:ext cx="1280160" cy="0"/>
-          </a:xfrm>
-          <a:prstGeom prst="line">
-            <a:avLst/>
-          </a:prstGeom>
-          <a:noFill/>
-          <a:ln w="19050">
+            <a:endParaRPr lang="en-US" sz="1700" dirty="0"/>
+          </a:p>
+        </p:txBody>
+      </p:sp>
+      <p:sp>
+        <p:nvSpPr>
+          <p:cNvPr id="18" name="Shape 13"/>
+          <p:cNvSpPr/>
+          <p:nvPr/>
+        </p:nvSpPr>
+        <p:spPr>
+          <a:xfrm>
+            <a:off x="4599432" y="1243584"/>
+            <a:ext cx="256032" cy="43891"/>
+          </a:xfrm>
+          <a:prstGeom prst="rect">
+            <a:avLst/>
+          </a:prstGeom>
+          <a:solidFill>
+            <a:srgbClr val="C8910A"/>
+          </a:solidFill>
+          <a:ln w="12700">
             <a:solidFill>
-              <a:srgbClr val="4A7C59"/>
+              <a:srgbClr val="C8910A"/>
             </a:solidFill>
             <a:prstDash val="solid"/>
           </a:ln>
         </p:spPr>
-      </p:sp>
-      <p:sp>
-        <p:nvSpPr>
-          <p:cNvPr id="16" name="Text 13"/>
-          <p:cNvSpPr/>
-          <p:nvPr/>
-        </p:nvSpPr>
-        <p:spPr>
-          <a:xfrm>
-            <a:off x="4709160" y="1463040"/>
-            <a:ext cx="4325112" cy="3291840"/>
+        <p:txBody>
+          <a:bodyPr/>
+          <a:lstStyle/>
+          <a:p>
+            <a:endParaRPr lang="en-US"/>
+          </a:p>
+        </p:txBody>
+      </p:sp>
+      <p:sp>
+        <p:nvSpPr>
+          <p:cNvPr id="19" name="Text 14"/>
+          <p:cNvSpPr/>
+          <p:nvPr/>
+        </p:nvSpPr>
+        <p:spPr>
+          <a:xfrm>
+            <a:off x="4599432" y="1408176"/>
+            <a:ext cx="4416552" cy="3429000"/>
           </a:xfrm>
           <a:prstGeom prst="rect">
             <a:avLst/>
@@ -1840,27 +1785,100 @@
           <a:bodyPr wrap="square" lIns="0" tIns="0" rIns="0" bIns="0" rtlCol="0" anchor="t"/>
           <a:lstStyle/>
           <a:p>
-            <a:pPr algn="l" indent="0" marL="0">
+            <a:pPr marL="0" indent="0" algn="l">
               <a:lnSpc>
                 <a:spcPct val="150000"/>
               </a:lnSpc>
               <a:buNone/>
             </a:pPr>
             <a:r>
-              <a:rPr lang="en-US" sz="1250" i="1" dirty="0">
+              <a:rPr lang="en-US" sz="1200" i="1" dirty="0">
                 <a:solidFill>
                   <a:srgbClr val="999999"/>
                 </a:solidFill>
-                <a:latin typeface="Calibri" pitchFamily="34" charset="0"/>
-                <a:ea typeface="Calibri" pitchFamily="34" charset="-122"/>
-                <a:cs typeface="Calibri" pitchFamily="34" charset="-120"/>
+                <a:latin typeface="IBM Plex Sans" pitchFamily="34" charset="0"/>
+                <a:ea typeface="IBM Plex Sans" pitchFamily="34" charset="-122"/>
+                <a:cs typeface="IBM Plex Sans" pitchFamily="34" charset="-120"/>
               </a:rPr>
-              <a:t>Describe the thinking behind this concept — what it represents, why the form and feeling fit the brief, how it connects to the SXSW-meets-Coachella energy of Project AIR.</a:t>
+              <a:t>Describe the thinking behind this concept - what it represents, why the form and feeling fit the brief, how it connects to the SXSW-meets-Coachella energy of Project AIR.</a:t>
             </a:r>
-            <a:endParaRPr lang="en-US" sz="1250" dirty="0"/>
-          </a:p>
-        </p:txBody>
-      </p:sp>
+            <a:endParaRPr lang="en-US" sz="1200" dirty="0"/>
+          </a:p>
+        </p:txBody>
+      </p:sp>
+      <p:pic>
+        <p:nvPicPr>
+          <p:cNvPr id="26" name="Graphic 25">
+            <a:extLst>
+              <a:ext uri="{FF2B5EF4-FFF2-40B4-BE49-F238E27FC236}">
+                <a16:creationId xmlns:a16="http://schemas.microsoft.com/office/drawing/2014/main" id="{115D2043-ED42-0AB7-1A99-87C081A16AA2}"/>
+              </a:ext>
+            </a:extLst>
+          </p:cNvPr>
+          <p:cNvPicPr>
+            <a:picLocks noChangeAspect="1"/>
+          </p:cNvPicPr>
+          <p:nvPr/>
+        </p:nvPicPr>
+        <p:blipFill>
+          <a:blip r:embed="rId5">
+            <a:extLst>
+              <a:ext uri="{96DAC541-7B7A-43D3-8B79-37D633B846F1}">
+                <asvg:svgBlip xmlns:asvg="http://schemas.microsoft.com/office/drawing/2016/SVG/main" r:embed="rId5"/>
+              </a:ext>
+            </a:extLst>
+          </a:blip>
+          <a:srcRect t="14657" b="55719"/>
+          <a:stretch>
+            <a:fillRect/>
+          </a:stretch>
+        </p:blipFill>
+        <p:spPr>
+          <a:xfrm>
+            <a:off x="5760720" y="-19698"/>
+            <a:ext cx="3410712" cy="568338"/>
+          </a:xfrm>
+          <a:prstGeom prst="rect">
+            <a:avLst/>
+          </a:prstGeom>
+        </p:spPr>
+      </p:pic>
+      <p:pic>
+        <p:nvPicPr>
+          <p:cNvPr id="30" name="Graphic 29">
+            <a:extLst>
+              <a:ext uri="{FF2B5EF4-FFF2-40B4-BE49-F238E27FC236}">
+                <a16:creationId xmlns:a16="http://schemas.microsoft.com/office/drawing/2014/main" id="{08F021CE-1693-8A7F-A0AF-994BD9B80323}"/>
+              </a:ext>
+            </a:extLst>
+          </p:cNvPr>
+          <p:cNvPicPr>
+            <a:picLocks noChangeAspect="1"/>
+          </p:cNvPicPr>
+          <p:nvPr/>
+        </p:nvPicPr>
+        <p:blipFill>
+          <a:blip r:embed="rId6">
+            <a:extLst>
+              <a:ext uri="{96DAC541-7B7A-43D3-8B79-37D633B846F1}">
+                <asvg:svgBlip xmlns:asvg="http://schemas.microsoft.com/office/drawing/2016/SVG/main" r:embed="rId6"/>
+              </a:ext>
+            </a:extLst>
+          </a:blip>
+          <a:stretch>
+            <a:fillRect/>
+          </a:stretch>
+        </p:blipFill>
+        <p:spPr>
+          <a:xfrm>
+            <a:off x="7621118" y="4338828"/>
+            <a:ext cx="1394865" cy="784974"/>
+          </a:xfrm>
+          <a:prstGeom prst="rect">
+            <a:avLst/>
+          </a:prstGeom>
+        </p:spPr>
+      </p:pic>
     </p:spTree>
   </p:cSld>
   <p:clrMapOvr>
@@ -1875,8 +1893,9 @@
     <p:bg>
       <p:bgPr>
         <a:solidFill>
-          <a:srgbClr val="F5F4F0"/>
+          <a:srgbClr val="EDEBE4"/>
         </a:solidFill>
+        <a:effectLst/>
       </p:bgPr>
     </p:bg>
     <p:spTree>
@@ -1895,63 +1914,132 @@
       </p:grpSpPr>
       <p:pic>
         <p:nvPicPr>
-          <p:cNvPr id="2" name="Image 0" descr="preencoded.png">    </p:cNvPr>
+          <p:cNvPr id="22" name="Image 0" descr="preencoded.png">
+            <a:extLst>
+              <a:ext uri="{FF2B5EF4-FFF2-40B4-BE49-F238E27FC236}">
+                <a16:creationId xmlns:a16="http://schemas.microsoft.com/office/drawing/2014/main" id="{61694D98-DFAE-4A79-E3A4-B8E863A7BBE9}"/>
+              </a:ext>
+            </a:extLst>
+          </p:cNvPr>
           <p:cNvPicPr>
             <a:picLocks noChangeAspect="1"/>
           </p:cNvPicPr>
           <p:nvPr/>
         </p:nvPicPr>
         <p:blipFill>
-          <a:blip r:embed="rId1"/>
+          <a:blip r:embed="rId3"/>
           <a:stretch>
             <a:fillRect/>
           </a:stretch>
         </p:blipFill>
         <p:spPr>
           <a:xfrm>
-            <a:off x="6903720" y="0"/>
-            <a:ext cx="2240280" cy="2240280"/>
+            <a:off x="91440" y="1188720"/>
+            <a:ext cx="9144000" cy="5143500"/>
           </a:xfrm>
           <a:prstGeom prst="rect">
             <a:avLst/>
           </a:prstGeom>
         </p:spPr>
       </p:pic>
-      <p:sp>
-        <p:nvSpPr>
-          <p:cNvPr id="3" name="Shape 0"/>
+      <p:pic>
+        <p:nvPicPr>
+          <p:cNvPr id="3" name="Image 1" descr="preencoded.png"/>
+          <p:cNvPicPr>
+            <a:picLocks noChangeAspect="1"/>
+          </p:cNvPicPr>
+          <p:nvPr/>
+        </p:nvPicPr>
+        <p:blipFill>
+          <a:blip r:embed="rId4"/>
+          <a:stretch>
+            <a:fillRect/>
+          </a:stretch>
+        </p:blipFill>
+        <p:spPr>
+          <a:xfrm>
+            <a:off x="7680960" y="0"/>
+            <a:ext cx="1463040" cy="1463040"/>
+          </a:xfrm>
+          <a:prstGeom prst="rect">
+            <a:avLst/>
+          </a:prstGeom>
+        </p:spPr>
+      </p:pic>
+      <p:sp>
+        <p:nvSpPr>
+          <p:cNvPr id="5" name="Shape 0"/>
           <p:cNvSpPr/>
           <p:nvPr/>
         </p:nvSpPr>
         <p:spPr>
           <a:xfrm>
             <a:off x="0" y="0"/>
-            <a:ext cx="9144000" cy="594360"/>
-          </a:xfrm>
-          <a:prstGeom prst="rect">
-            <a:avLst/>
-          </a:prstGeom>
-          <a:solidFill>
-            <a:srgbClr val="1B3A2D"/>
+            <a:ext cx="9144000" cy="548640"/>
+          </a:xfrm>
+          <a:prstGeom prst="rect">
+            <a:avLst/>
+          </a:prstGeom>
+          <a:solidFill>
+            <a:srgbClr val="111111"/>
           </a:solidFill>
           <a:ln w="12700">
             <a:solidFill>
-              <a:srgbClr val="1B3A2D"/>
+              <a:srgbClr val="111111"/>
             </a:solidFill>
             <a:prstDash val="solid"/>
           </a:ln>
         </p:spPr>
-      </p:sp>
-      <p:sp>
-        <p:nvSpPr>
-          <p:cNvPr id="4" name="Text 1"/>
-          <p:cNvSpPr/>
-          <p:nvPr/>
-        </p:nvSpPr>
-        <p:spPr>
-          <a:xfrm>
-            <a:off x="320040" y="0"/>
-            <a:ext cx="5029200" cy="594360"/>
+        <p:txBody>
+          <a:bodyPr/>
+          <a:lstStyle/>
+          <a:p>
+            <a:endParaRPr lang="en-US"/>
+          </a:p>
+        </p:txBody>
+      </p:sp>
+      <p:sp>
+        <p:nvSpPr>
+          <p:cNvPr id="6" name="Shape 1"/>
+          <p:cNvSpPr/>
+          <p:nvPr/>
+        </p:nvSpPr>
+        <p:spPr>
+          <a:xfrm>
+            <a:off x="164592" y="219456"/>
+            <a:ext cx="109728" cy="109728"/>
+          </a:xfrm>
+          <a:prstGeom prst="ellipse">
+            <a:avLst/>
+          </a:prstGeom>
+          <a:solidFill>
+            <a:srgbClr val="C8910A"/>
+          </a:solidFill>
+          <a:ln w="12700">
+            <a:solidFill>
+              <a:srgbClr val="C8910A"/>
+            </a:solidFill>
+            <a:prstDash val="solid"/>
+          </a:ln>
+        </p:spPr>
+        <p:txBody>
+          <a:bodyPr/>
+          <a:lstStyle/>
+          <a:p>
+            <a:endParaRPr lang="en-US"/>
+          </a:p>
+        </p:txBody>
+      </p:sp>
+      <p:sp>
+        <p:nvSpPr>
+          <p:cNvPr id="7" name="Text 2"/>
+          <p:cNvSpPr/>
+          <p:nvPr/>
+        </p:nvSpPr>
+        <p:spPr>
+          <a:xfrm>
+            <a:off x="365760" y="0"/>
+            <a:ext cx="5029200" cy="548640"/>
           </a:xfrm>
           <a:prstGeom prst="rect">
             <a:avLst/>
@@ -1963,34 +2051,34 @@
           <a:bodyPr wrap="square" lIns="0" tIns="0" rIns="0" bIns="0" rtlCol="0" anchor="ctr"/>
           <a:lstStyle/>
           <a:p>
-            <a:pPr algn="l" indent="0" marL="0">
+            <a:pPr marL="0" indent="0" algn="l">
               <a:buNone/>
             </a:pPr>
             <a:r>
-              <a:rPr lang="en-US" sz="2100" b="1" spc="100" kern="0" dirty="0">
+              <a:rPr lang="en-US" sz="1900" b="1" kern="0" spc="100" dirty="0">
                 <a:solidFill>
                   <a:srgbClr val="FFFFFF"/>
                 </a:solidFill>
-                <a:latin typeface="Calibri" pitchFamily="34" charset="0"/>
-                <a:ea typeface="Calibri" pitchFamily="34" charset="-122"/>
-                <a:cs typeface="Calibri" pitchFamily="34" charset="-120"/>
+                <a:latin typeface="Century Gothic" pitchFamily="34" charset="0"/>
+                <a:ea typeface="Century Gothic" pitchFamily="34" charset="-122"/>
+                <a:cs typeface="Century Gothic" pitchFamily="34" charset="-120"/>
               </a:rPr>
               <a:t>Concept B</a:t>
             </a:r>
-            <a:endParaRPr lang="en-US" sz="2100" dirty="0"/>
-          </a:p>
-        </p:txBody>
-      </p:sp>
-      <p:sp>
-        <p:nvSpPr>
-          <p:cNvPr id="5" name="Shape 2"/>
-          <p:cNvSpPr/>
-          <p:nvPr/>
-        </p:nvSpPr>
-        <p:spPr>
-          <a:xfrm>
-            <a:off x="0" y="594360"/>
-            <a:ext cx="4434840" cy="2274570"/>
+            <a:endParaRPr lang="en-US" sz="1900" dirty="0"/>
+          </a:p>
+        </p:txBody>
+      </p:sp>
+      <p:sp>
+        <p:nvSpPr>
+          <p:cNvPr id="8" name="Shape 3"/>
+          <p:cNvSpPr/>
+          <p:nvPr/>
+        </p:nvSpPr>
+        <p:spPr>
+          <a:xfrm>
+            <a:off x="0" y="548640"/>
+            <a:ext cx="4251960" cy="2297430"/>
           </a:xfrm>
           <a:prstGeom prst="rect">
             <a:avLst/>
@@ -2000,22 +2088,29 @@
           </a:solidFill>
           <a:ln w="6350">
             <a:solidFill>
-              <a:srgbClr val="E8E3DD"/>
+              <a:srgbClr val="DDD8D2"/>
             </a:solidFill>
             <a:prstDash val="solid"/>
           </a:ln>
         </p:spPr>
-      </p:sp>
-      <p:sp>
-        <p:nvSpPr>
-          <p:cNvPr id="6" name="Text 3"/>
-          <p:cNvSpPr/>
-          <p:nvPr/>
-        </p:nvSpPr>
-        <p:spPr>
-          <a:xfrm>
-            <a:off x="91440" y="685800"/>
-            <a:ext cx="4251960" cy="256032"/>
+        <p:txBody>
+          <a:bodyPr/>
+          <a:lstStyle/>
+          <a:p>
+            <a:endParaRPr lang="en-US"/>
+          </a:p>
+        </p:txBody>
+      </p:sp>
+      <p:sp>
+        <p:nvSpPr>
+          <p:cNvPr id="9" name="Text 4"/>
+          <p:cNvSpPr/>
+          <p:nvPr/>
+        </p:nvSpPr>
+        <p:spPr>
+          <a:xfrm>
+            <a:off x="91440" y="640080"/>
+            <a:ext cx="4069080" cy="219456"/>
           </a:xfrm>
           <a:prstGeom prst="rect">
             <a:avLst/>
@@ -2027,17 +2122,17 @@
           <a:bodyPr wrap="square" lIns="0" tIns="0" rIns="0" bIns="0" rtlCol="0" anchor="ctr"/>
           <a:lstStyle/>
           <a:p>
-            <a:pPr algn="ctr" indent="0" marL="0">
+            <a:pPr marL="0" indent="0" algn="ctr">
               <a:buNone/>
             </a:pPr>
             <a:r>
-              <a:rPr lang="en-US" sz="700" spc="300" kern="0" dirty="0">
+              <a:rPr lang="en-US" sz="700" kern="0" spc="300" dirty="0">
                 <a:solidFill>
                   <a:srgbClr val="AAAAAA"/>
                 </a:solidFill>
-                <a:latin typeface="Calibri" pitchFamily="34" charset="0"/>
-                <a:ea typeface="Calibri" pitchFamily="34" charset="-122"/>
-                <a:cs typeface="Calibri" pitchFamily="34" charset="-120"/>
+                <a:latin typeface="IBM Plex Sans" pitchFamily="34" charset="0"/>
+                <a:ea typeface="IBM Plex Sans" pitchFamily="34" charset="-122"/>
+                <a:cs typeface="IBM Plex Sans" pitchFamily="34" charset="-120"/>
               </a:rPr>
               <a:t>LIGHT BACKGROUND</a:t>
             </a:r>
@@ -2047,14 +2142,14 @@
       </p:sp>
       <p:sp>
         <p:nvSpPr>
-          <p:cNvPr id="7" name="Shape 4"/>
-          <p:cNvSpPr/>
-          <p:nvPr/>
-        </p:nvSpPr>
-        <p:spPr>
-          <a:xfrm>
-            <a:off x="960120" y="1228725"/>
-            <a:ext cx="2514600" cy="1188720"/>
+          <p:cNvPr id="10" name="Shape 5"/>
+          <p:cNvSpPr/>
+          <p:nvPr/>
+        </p:nvSpPr>
+        <p:spPr>
+          <a:xfrm>
+            <a:off x="914400" y="1231011"/>
+            <a:ext cx="2423160" cy="1078992"/>
           </a:xfrm>
           <a:prstGeom prst="rect">
             <a:avLst/>
@@ -2069,17 +2164,24 @@
             <a:prstDash val="dash"/>
           </a:ln>
         </p:spPr>
-      </p:sp>
-      <p:sp>
-        <p:nvSpPr>
-          <p:cNvPr id="8" name="Text 5"/>
-          <p:cNvSpPr/>
-          <p:nvPr/>
-        </p:nvSpPr>
-        <p:spPr>
-          <a:xfrm>
-            <a:off x="960120" y="1228725"/>
-            <a:ext cx="2514600" cy="1188720"/>
+        <p:txBody>
+          <a:bodyPr/>
+          <a:lstStyle/>
+          <a:p>
+            <a:endParaRPr lang="en-US"/>
+          </a:p>
+        </p:txBody>
+      </p:sp>
+      <p:sp>
+        <p:nvSpPr>
+          <p:cNvPr id="11" name="Text 6"/>
+          <p:cNvSpPr/>
+          <p:nvPr/>
+        </p:nvSpPr>
+        <p:spPr>
+          <a:xfrm>
+            <a:off x="914400" y="1231011"/>
+            <a:ext cx="2423160" cy="1078992"/>
           </a:xfrm>
           <a:prstGeom prst="rect">
             <a:avLst/>
@@ -2091,7 +2193,7 @@
           <a:bodyPr wrap="square" lIns="0" tIns="0" rIns="0" bIns="0" rtlCol="0" anchor="ctr"/>
           <a:lstStyle/>
           <a:p>
-            <a:pPr algn="ctr" indent="0" marL="0">
+            <a:pPr marL="0" indent="0" algn="ctr">
               <a:buNone/>
             </a:pPr>
             <a:r>
@@ -2099,11 +2201,11 @@
                 <a:solidFill>
                   <a:srgbClr val="AAAAAA"/>
                 </a:solidFill>
-                <a:latin typeface="Calibri" pitchFamily="34" charset="0"/>
-                <a:ea typeface="Calibri" pitchFamily="34" charset="-122"/>
-                <a:cs typeface="Calibri" pitchFamily="34" charset="-120"/>
+                <a:latin typeface="IBM Plex Sans" pitchFamily="34" charset="0"/>
+                <a:ea typeface="IBM Plex Sans" pitchFamily="34" charset="-122"/>
+                <a:cs typeface="IBM Plex Sans" pitchFamily="34" charset="-120"/>
               </a:rPr>
-              <a:t>Logo — Light Background</a:t>
+              <a:t>Logo - Light Background</a:t>
             </a:r>
             <a:endParaRPr lang="en-US" sz="1000" dirty="0"/>
           </a:p>
@@ -2111,39 +2213,46 @@
       </p:sp>
       <p:sp>
         <p:nvSpPr>
-          <p:cNvPr id="9" name="Shape 6"/>
-          <p:cNvSpPr/>
-          <p:nvPr/>
-        </p:nvSpPr>
-        <p:spPr>
-          <a:xfrm>
-            <a:off x="0" y="2868930"/>
-            <a:ext cx="4434840" cy="2274570"/>
-          </a:xfrm>
-          <a:prstGeom prst="rect">
-            <a:avLst/>
-          </a:prstGeom>
-          <a:solidFill>
-            <a:srgbClr val="1A1A1A"/>
+          <p:cNvPr id="12" name="Shape 7"/>
+          <p:cNvSpPr/>
+          <p:nvPr/>
+        </p:nvSpPr>
+        <p:spPr>
+          <a:xfrm>
+            <a:off x="0" y="2846070"/>
+            <a:ext cx="4251960" cy="2297430"/>
+          </a:xfrm>
+          <a:prstGeom prst="rect">
+            <a:avLst/>
+          </a:prstGeom>
+          <a:solidFill>
+            <a:srgbClr val="111111"/>
           </a:solidFill>
           <a:ln w="12700">
             <a:solidFill>
-              <a:srgbClr val="1A1A1A"/>
+              <a:srgbClr val="111111"/>
             </a:solidFill>
             <a:prstDash val="solid"/>
           </a:ln>
         </p:spPr>
-      </p:sp>
-      <p:sp>
-        <p:nvSpPr>
-          <p:cNvPr id="10" name="Text 7"/>
-          <p:cNvSpPr/>
-          <p:nvPr/>
-        </p:nvSpPr>
-        <p:spPr>
-          <a:xfrm>
-            <a:off x="91440" y="2960370"/>
-            <a:ext cx="4251960" cy="256032"/>
+        <p:txBody>
+          <a:bodyPr/>
+          <a:lstStyle/>
+          <a:p>
+            <a:endParaRPr lang="en-US"/>
+          </a:p>
+        </p:txBody>
+      </p:sp>
+      <p:sp>
+        <p:nvSpPr>
+          <p:cNvPr id="13" name="Text 8"/>
+          <p:cNvSpPr/>
+          <p:nvPr/>
+        </p:nvSpPr>
+        <p:spPr>
+          <a:xfrm>
+            <a:off x="91440" y="2937510"/>
+            <a:ext cx="4069080" cy="219456"/>
           </a:xfrm>
           <a:prstGeom prst="rect">
             <a:avLst/>
@@ -2155,17 +2264,17 @@
           <a:bodyPr wrap="square" lIns="0" tIns="0" rIns="0" bIns="0" rtlCol="0" anchor="ctr"/>
           <a:lstStyle/>
           <a:p>
-            <a:pPr algn="ctr" indent="0" marL="0">
+            <a:pPr marL="0" indent="0" algn="ctr">
               <a:buNone/>
             </a:pPr>
             <a:r>
-              <a:rPr lang="en-US" sz="700" spc="300" kern="0" dirty="0">
+              <a:rPr lang="en-US" sz="700" kern="0" spc="300" dirty="0">
                 <a:solidFill>
-                  <a:srgbClr val="666666"/>
+                  <a:srgbClr val="494949"/>
                 </a:solidFill>
-                <a:latin typeface="Calibri" pitchFamily="34" charset="0"/>
-                <a:ea typeface="Calibri" pitchFamily="34" charset="-122"/>
-                <a:cs typeface="Calibri" pitchFamily="34" charset="-120"/>
+                <a:latin typeface="IBM Plex Sans" pitchFamily="34" charset="0"/>
+                <a:ea typeface="IBM Plex Sans" pitchFamily="34" charset="-122"/>
+                <a:cs typeface="IBM Plex Sans" pitchFamily="34" charset="-120"/>
               </a:rPr>
               <a:t>DARK BACKGROUND</a:t>
             </a:r>
@@ -2175,39 +2284,46 @@
       </p:sp>
       <p:sp>
         <p:nvSpPr>
-          <p:cNvPr id="11" name="Shape 8"/>
-          <p:cNvSpPr/>
-          <p:nvPr/>
-        </p:nvSpPr>
-        <p:spPr>
-          <a:xfrm>
-            <a:off x="960120" y="3503295"/>
-            <a:ext cx="2514600" cy="1188720"/>
-          </a:xfrm>
-          <a:prstGeom prst="rect">
-            <a:avLst/>
-          </a:prstGeom>
-          <a:solidFill>
-            <a:srgbClr val="1A1A1A"/>
+          <p:cNvPr id="14" name="Shape 9"/>
+          <p:cNvSpPr/>
+          <p:nvPr/>
+        </p:nvSpPr>
+        <p:spPr>
+          <a:xfrm>
+            <a:off x="914400" y="3528441"/>
+            <a:ext cx="2423160" cy="1078992"/>
+          </a:xfrm>
+          <a:prstGeom prst="rect">
+            <a:avLst/>
+          </a:prstGeom>
+          <a:solidFill>
+            <a:srgbClr val="111111"/>
           </a:solidFill>
           <a:ln w="9525">
             <a:solidFill>
-              <a:srgbClr val="4A4A4A"/>
+              <a:srgbClr val="3A3A3A"/>
             </a:solidFill>
             <a:prstDash val="dash"/>
           </a:ln>
         </p:spPr>
-      </p:sp>
-      <p:sp>
-        <p:nvSpPr>
-          <p:cNvPr id="12" name="Text 9"/>
-          <p:cNvSpPr/>
-          <p:nvPr/>
-        </p:nvSpPr>
-        <p:spPr>
-          <a:xfrm>
-            <a:off x="960120" y="3503295"/>
-            <a:ext cx="2514600" cy="1188720"/>
+        <p:txBody>
+          <a:bodyPr/>
+          <a:lstStyle/>
+          <a:p>
+            <a:endParaRPr lang="en-US"/>
+          </a:p>
+        </p:txBody>
+      </p:sp>
+      <p:sp>
+        <p:nvSpPr>
+          <p:cNvPr id="15" name="Text 10"/>
+          <p:cNvSpPr/>
+          <p:nvPr/>
+        </p:nvSpPr>
+        <p:spPr>
+          <a:xfrm>
+            <a:off x="914400" y="3528441"/>
+            <a:ext cx="2423160" cy="1078992"/>
           </a:xfrm>
           <a:prstGeom prst="rect">
             <a:avLst/>
@@ -2219,19 +2335,19 @@
           <a:bodyPr wrap="square" lIns="0" tIns="0" rIns="0" bIns="0" rtlCol="0" anchor="ctr"/>
           <a:lstStyle/>
           <a:p>
-            <a:pPr algn="ctr" indent="0" marL="0">
+            <a:pPr marL="0" indent="0" algn="ctr">
               <a:buNone/>
             </a:pPr>
             <a:r>
               <a:rPr lang="en-US" sz="1000" i="1" dirty="0">
                 <a:solidFill>
-                  <a:srgbClr val="666666"/>
+                  <a:srgbClr val="505050"/>
                 </a:solidFill>
-                <a:latin typeface="Calibri" pitchFamily="34" charset="0"/>
-                <a:ea typeface="Calibri" pitchFamily="34" charset="-122"/>
-                <a:cs typeface="Calibri" pitchFamily="34" charset="-120"/>
+                <a:latin typeface="IBM Plex Sans" pitchFamily="34" charset="0"/>
+                <a:ea typeface="IBM Plex Sans" pitchFamily="34" charset="-122"/>
+                <a:cs typeface="IBM Plex Sans" pitchFamily="34" charset="-120"/>
               </a:rPr>
-              <a:t>Logo — Dark Background</a:t>
+              <a:t>Logo - Dark Background</a:t>
             </a:r>
             <a:endParaRPr lang="en-US" sz="1000" dirty="0"/>
           </a:p>
@@ -2239,14 +2355,14 @@
       </p:sp>
       <p:sp>
         <p:nvSpPr>
-          <p:cNvPr id="13" name="Shape 10"/>
-          <p:cNvSpPr/>
-          <p:nvPr/>
-        </p:nvSpPr>
-        <p:spPr>
-          <a:xfrm>
-            <a:off x="4434840" y="594360"/>
-            <a:ext cx="0" cy="4549140"/>
+          <p:cNvPr id="16" name="Shape 11"/>
+          <p:cNvSpPr/>
+          <p:nvPr/>
+        </p:nvSpPr>
+        <p:spPr>
+          <a:xfrm>
+            <a:off x="4251960" y="548640"/>
+            <a:ext cx="0" cy="4594860"/>
           </a:xfrm>
           <a:prstGeom prst="line">
             <a:avLst/>
@@ -2254,22 +2370,29 @@
           <a:noFill/>
           <a:ln w="9525">
             <a:solidFill>
-              <a:srgbClr val="D0C8BF"/>
+              <a:srgbClr val="CEC9C2"/>
             </a:solidFill>
             <a:prstDash val="solid"/>
           </a:ln>
         </p:spPr>
-      </p:sp>
-      <p:sp>
-        <p:nvSpPr>
-          <p:cNvPr id="14" name="Text 11"/>
-          <p:cNvSpPr/>
-          <p:nvPr/>
-        </p:nvSpPr>
-        <p:spPr>
-          <a:xfrm>
-            <a:off x="4709160" y="841248"/>
-            <a:ext cx="4325112" cy="402336"/>
+        <p:txBody>
+          <a:bodyPr/>
+          <a:lstStyle/>
+          <a:p>
+            <a:endParaRPr lang="en-US"/>
+          </a:p>
+        </p:txBody>
+      </p:sp>
+      <p:sp>
+        <p:nvSpPr>
+          <p:cNvPr id="17" name="Text 12"/>
+          <p:cNvSpPr/>
+          <p:nvPr/>
+        </p:nvSpPr>
+        <p:spPr>
+          <a:xfrm>
+            <a:off x="4599432" y="804672"/>
+            <a:ext cx="4416552" cy="384048"/>
           </a:xfrm>
           <a:prstGeom prst="rect">
             <a:avLst/>
@@ -2281,57 +2404,66 @@
           <a:bodyPr wrap="square" lIns="0" tIns="0" rIns="0" bIns="0" rtlCol="0" anchor="ctr"/>
           <a:lstStyle/>
           <a:p>
-            <a:pPr algn="l" indent="0" marL="0">
+            <a:pPr marL="0" indent="0" algn="l">
               <a:buNone/>
             </a:pPr>
             <a:r>
-              <a:rPr lang="en-US" sz="1800" b="1" dirty="0">
+              <a:rPr lang="en-US" sz="1700" b="1" dirty="0">
                 <a:solidFill>
-                  <a:srgbClr val="1B3A2D"/>
+                  <a:srgbClr val="111111"/>
                 </a:solidFill>
-                <a:latin typeface="Calibri" pitchFamily="34" charset="0"/>
-                <a:ea typeface="Calibri" pitchFamily="34" charset="-122"/>
-                <a:cs typeface="Calibri" pitchFamily="34" charset="-120"/>
+                <a:latin typeface="Century Gothic" pitchFamily="34" charset="0"/>
+                <a:ea typeface="Century Gothic" pitchFamily="34" charset="-122"/>
+                <a:cs typeface="Century Gothic" pitchFamily="34" charset="-120"/>
               </a:rPr>
               <a:t>Rationale</a:t>
             </a:r>
-            <a:endParaRPr lang="en-US" sz="1800" dirty="0"/>
-          </a:p>
-        </p:txBody>
-      </p:sp>
-      <p:sp>
-        <p:nvSpPr>
-          <p:cNvPr id="15" name="Shape 12"/>
-          <p:cNvSpPr/>
-          <p:nvPr/>
-        </p:nvSpPr>
-        <p:spPr>
-          <a:xfrm>
-            <a:off x="4709160" y="1307592"/>
-            <a:ext cx="1280160" cy="0"/>
-          </a:xfrm>
-          <a:prstGeom prst="line">
-            <a:avLst/>
-          </a:prstGeom>
-          <a:noFill/>
-          <a:ln w="19050">
+            <a:endParaRPr lang="en-US" sz="1700" dirty="0"/>
+          </a:p>
+        </p:txBody>
+      </p:sp>
+      <p:sp>
+        <p:nvSpPr>
+          <p:cNvPr id="18" name="Shape 13"/>
+          <p:cNvSpPr/>
+          <p:nvPr/>
+        </p:nvSpPr>
+        <p:spPr>
+          <a:xfrm>
+            <a:off x="4599432" y="1243584"/>
+            <a:ext cx="256032" cy="43891"/>
+          </a:xfrm>
+          <a:prstGeom prst="rect">
+            <a:avLst/>
+          </a:prstGeom>
+          <a:solidFill>
+            <a:srgbClr val="C8910A"/>
+          </a:solidFill>
+          <a:ln w="12700">
             <a:solidFill>
-              <a:srgbClr val="4A7C59"/>
+              <a:srgbClr val="C8910A"/>
             </a:solidFill>
             <a:prstDash val="solid"/>
           </a:ln>
         </p:spPr>
-      </p:sp>
-      <p:sp>
-        <p:nvSpPr>
-          <p:cNvPr id="16" name="Text 13"/>
-          <p:cNvSpPr/>
-          <p:nvPr/>
-        </p:nvSpPr>
-        <p:spPr>
-          <a:xfrm>
-            <a:off x="4709160" y="1463040"/>
-            <a:ext cx="4325112" cy="3291840"/>
+        <p:txBody>
+          <a:bodyPr/>
+          <a:lstStyle/>
+          <a:p>
+            <a:endParaRPr lang="en-US"/>
+          </a:p>
+        </p:txBody>
+      </p:sp>
+      <p:sp>
+        <p:nvSpPr>
+          <p:cNvPr id="19" name="Text 14"/>
+          <p:cNvSpPr/>
+          <p:nvPr/>
+        </p:nvSpPr>
+        <p:spPr>
+          <a:xfrm>
+            <a:off x="4599432" y="1408176"/>
+            <a:ext cx="4416552" cy="3429000"/>
           </a:xfrm>
           <a:prstGeom prst="rect">
             <a:avLst/>
@@ -2343,27 +2475,64 @@
           <a:bodyPr wrap="square" lIns="0" tIns="0" rIns="0" bIns="0" rtlCol="0" anchor="t"/>
           <a:lstStyle/>
           <a:p>
-            <a:pPr algn="l" indent="0" marL="0">
+            <a:pPr marL="0" indent="0" algn="l">
               <a:lnSpc>
                 <a:spcPct val="150000"/>
               </a:lnSpc>
               <a:buNone/>
             </a:pPr>
             <a:r>
-              <a:rPr lang="en-US" sz="1250" i="1" dirty="0">
+              <a:rPr lang="en-US" sz="1200" i="1" dirty="0">
                 <a:solidFill>
                   <a:srgbClr val="999999"/>
                 </a:solidFill>
-                <a:latin typeface="Calibri" pitchFamily="34" charset="0"/>
-                <a:ea typeface="Calibri" pitchFamily="34" charset="-122"/>
-                <a:cs typeface="Calibri" pitchFamily="34" charset="-120"/>
+                <a:latin typeface="IBM Plex Sans" pitchFamily="34" charset="0"/>
+                <a:ea typeface="IBM Plex Sans" pitchFamily="34" charset="-122"/>
+                <a:cs typeface="IBM Plex Sans" pitchFamily="34" charset="-120"/>
               </a:rPr>
-              <a:t>Describe the thinking behind this concept — what it represents, why the form and feeling fit the brief, how it connects to the SXSW-meets-Coachella energy of Project AIR.</a:t>
+              <a:t>Describe the thinking behind this concept - what it represents, why the form and feeling fit the brief, how it connects to the SXSW-meets-Coachella energy of Project AIR.</a:t>
             </a:r>
-            <a:endParaRPr lang="en-US" sz="1250" dirty="0"/>
-          </a:p>
-        </p:txBody>
-      </p:sp>
+            <a:endParaRPr lang="en-US" sz="1200" dirty="0"/>
+          </a:p>
+        </p:txBody>
+      </p:sp>
+      <p:pic>
+        <p:nvPicPr>
+          <p:cNvPr id="20" name="Graphic 19">
+            <a:extLst>
+              <a:ext uri="{FF2B5EF4-FFF2-40B4-BE49-F238E27FC236}">
+                <a16:creationId xmlns:a16="http://schemas.microsoft.com/office/drawing/2014/main" id="{0773CB11-1D73-6AD1-9F78-0B2B4E9EDB57}"/>
+              </a:ext>
+            </a:extLst>
+          </p:cNvPr>
+          <p:cNvPicPr>
+            <a:picLocks noChangeAspect="1"/>
+          </p:cNvPicPr>
+          <p:nvPr/>
+        </p:nvPicPr>
+        <p:blipFill>
+          <a:blip r:embed="rId5">
+            <a:extLst>
+              <a:ext uri="{96DAC541-7B7A-43D3-8B79-37D633B846F1}">
+                <asvg:svgBlip xmlns:asvg="http://schemas.microsoft.com/office/drawing/2016/SVG/main" r:embed="rId5"/>
+              </a:ext>
+            </a:extLst>
+          </a:blip>
+          <a:srcRect t="46186" b="25215"/>
+          <a:stretch>
+            <a:fillRect/>
+          </a:stretch>
+        </p:blipFill>
+        <p:spPr>
+          <a:xfrm>
+            <a:off x="5760720" y="0"/>
+            <a:ext cx="3410712" cy="548640"/>
+          </a:xfrm>
+          <a:prstGeom prst="rect">
+            <a:avLst/>
+          </a:prstGeom>
+        </p:spPr>
+      </p:pic>
     </p:spTree>
   </p:cSld>
   <p:clrMapOvr>
@@ -2378,8 +2547,9 @@
     <p:bg>
       <p:bgPr>
         <a:solidFill>
-          <a:srgbClr val="131F16"/>
+          <a:srgbClr val="111111"/>
         </a:solidFill>
+        <a:effectLst/>
       </p:bgPr>
     </p:bg>
     <p:spTree>
@@ -2398,22 +2568,22 @@
       </p:grpSpPr>
       <p:pic>
         <p:nvPicPr>
-          <p:cNvPr id="2" name="Image 0" descr="preencoded.png">    </p:cNvPr>
+          <p:cNvPr id="3" name="Image 1" descr="preencoded.png"/>
           <p:cNvPicPr>
             <a:picLocks noChangeAspect="1"/>
           </p:cNvPicPr>
           <p:nvPr/>
         </p:nvPicPr>
         <p:blipFill>
-          <a:blip r:embed="rId1"/>
+          <a:blip r:embed="rId3"/>
           <a:stretch>
             <a:fillRect/>
           </a:stretch>
         </p:blipFill>
         <p:spPr>
           <a:xfrm>
-            <a:off x="6903720" y="2857500"/>
-            <a:ext cx="2240280" cy="2286000"/>
+            <a:off x="0" y="0"/>
+            <a:ext cx="9144000" cy="5143500"/>
           </a:xfrm>
           <a:prstGeom prst="rect">
             <a:avLst/>
@@ -2422,39 +2592,161 @@
       </p:pic>
       <p:sp>
         <p:nvSpPr>
-          <p:cNvPr id="3" name="Shape 0"/>
-          <p:cNvSpPr/>
-          <p:nvPr/>
-        </p:nvSpPr>
-        <p:spPr>
-          <a:xfrm>
-            <a:off x="0" y="0"/>
-            <a:ext cx="256032" cy="5143500"/>
-          </a:xfrm>
-          <a:prstGeom prst="rect">
-            <a:avLst/>
-          </a:prstGeom>
-          <a:solidFill>
-            <a:srgbClr val="2D5A3D"/>
+          <p:cNvPr id="4" name="Text 0"/>
+          <p:cNvSpPr/>
+          <p:nvPr/>
+        </p:nvSpPr>
+        <p:spPr>
+          <a:xfrm rot="16200000">
+            <a:off x="-1097280" y="1938528"/>
+            <a:ext cx="2514600" cy="329184"/>
+          </a:xfrm>
+          <a:prstGeom prst="rect">
+            <a:avLst/>
+          </a:prstGeom>
+          <a:noFill/>
+          <a:ln/>
+        </p:spPr>
+        <p:txBody>
+          <a:bodyPr wrap="square" lIns="0" tIns="0" rIns="0" bIns="0" rtlCol="0" anchor="ctr"/>
+          <a:lstStyle/>
+          <a:p>
+            <a:pPr marL="0" indent="0" algn="ctr">
+              <a:buNone/>
+            </a:pPr>
+            <a:r>
+              <a:rPr lang="en-US" sz="900" b="1" kern="0" spc="600" dirty="0">
+                <a:solidFill>
+                  <a:srgbClr val="C8910A"/>
+                </a:solidFill>
+                <a:latin typeface="Century Gothic" pitchFamily="34" charset="0"/>
+                <a:ea typeface="Century Gothic" pitchFamily="34" charset="-122"/>
+                <a:cs typeface="Century Gothic" pitchFamily="34" charset="-120"/>
+              </a:rPr>
+              <a:t>AI IN REACH</a:t>
+            </a:r>
+            <a:endParaRPr lang="en-US" sz="900" dirty="0"/>
+          </a:p>
+        </p:txBody>
+      </p:sp>
+      <p:sp>
+        <p:nvSpPr>
+          <p:cNvPr id="5" name="Text 1"/>
+          <p:cNvSpPr/>
+          <p:nvPr/>
+        </p:nvSpPr>
+        <p:spPr>
+          <a:xfrm>
+            <a:off x="475488" y="347472"/>
+            <a:ext cx="7772400" cy="822960"/>
+          </a:xfrm>
+          <a:prstGeom prst="rect">
+            <a:avLst/>
+          </a:prstGeom>
+          <a:noFill/>
+          <a:ln/>
+        </p:spPr>
+        <p:txBody>
+          <a:bodyPr wrap="square" lIns="0" tIns="0" rIns="0" bIns="0" rtlCol="0" anchor="ctr"/>
+          <a:lstStyle/>
+          <a:p>
+            <a:pPr marL="0" indent="0" algn="l">
+              <a:buNone/>
+            </a:pPr>
+            <a:r>
+              <a:rPr lang="en-US" sz="4400" b="1" kern="0" spc="400" dirty="0">
+                <a:solidFill>
+                  <a:srgbClr val="FFFFFF"/>
+                </a:solidFill>
+                <a:latin typeface="Century Gothic" pitchFamily="34" charset="0"/>
+                <a:ea typeface="Century Gothic" pitchFamily="34" charset="-122"/>
+                <a:cs typeface="Century Gothic" pitchFamily="34" charset="-120"/>
+              </a:rPr>
+              <a:t>NEXT STEPS</a:t>
+            </a:r>
+            <a:endParaRPr lang="en-US" sz="4400" dirty="0"/>
+          </a:p>
+        </p:txBody>
+      </p:sp>
+      <p:sp>
+        <p:nvSpPr>
+          <p:cNvPr id="6" name="Shape 2"/>
+          <p:cNvSpPr/>
+          <p:nvPr/>
+        </p:nvSpPr>
+        <p:spPr>
+          <a:xfrm>
+            <a:off x="475488" y="1243584"/>
+            <a:ext cx="256032" cy="43891"/>
+          </a:xfrm>
+          <a:prstGeom prst="rect">
+            <a:avLst/>
+          </a:prstGeom>
+          <a:solidFill>
+            <a:srgbClr val="C8910A"/>
           </a:solidFill>
           <a:ln w="12700">
             <a:solidFill>
-              <a:srgbClr val="2D5A3D"/>
+              <a:srgbClr val="C8910A"/>
             </a:solidFill>
             <a:prstDash val="solid"/>
           </a:ln>
         </p:spPr>
-      </p:sp>
-      <p:sp>
-        <p:nvSpPr>
-          <p:cNvPr id="4" name="Text 1"/>
-          <p:cNvSpPr/>
-          <p:nvPr/>
-        </p:nvSpPr>
-        <p:spPr>
-          <a:xfrm>
-            <a:off x="502920" y="347472"/>
-            <a:ext cx="8229600" cy="777240"/>
+        <p:txBody>
+          <a:bodyPr/>
+          <a:lstStyle/>
+          <a:p>
+            <a:endParaRPr lang="en-US"/>
+          </a:p>
+        </p:txBody>
+      </p:sp>
+      <p:pic>
+        <p:nvPicPr>
+          <p:cNvPr id="15" name="Graphic 14">
+            <a:extLst>
+              <a:ext uri="{FF2B5EF4-FFF2-40B4-BE49-F238E27FC236}">
+                <a16:creationId xmlns:a16="http://schemas.microsoft.com/office/drawing/2014/main" id="{72BEAFBE-57EC-A26E-481E-06DF24527DDB}"/>
+              </a:ext>
+            </a:extLst>
+          </p:cNvPr>
+          <p:cNvPicPr>
+            <a:picLocks noChangeAspect="1"/>
+          </p:cNvPicPr>
+          <p:nvPr/>
+        </p:nvPicPr>
+        <p:blipFill>
+          <a:blip r:embed="rId4">
+            <a:extLst>
+              <a:ext uri="{96DAC541-7B7A-43D3-8B79-37D633B846F1}">
+                <asvg:svgBlip xmlns:asvg="http://schemas.microsoft.com/office/drawing/2016/SVG/main" r:embed="rId4"/>
+              </a:ext>
+            </a:extLst>
+          </a:blip>
+          <a:srcRect l="79323"/>
+          <a:stretch>
+            <a:fillRect/>
+          </a:stretch>
+        </p:blipFill>
+        <p:spPr>
+          <a:xfrm>
+            <a:off x="8247888" y="0"/>
+            <a:ext cx="896112" cy="5143500"/>
+          </a:xfrm>
+          <a:prstGeom prst="rect">
+            <a:avLst/>
+          </a:prstGeom>
+        </p:spPr>
+      </p:pic>
+      <p:sp>
+        <p:nvSpPr>
+          <p:cNvPr id="99" name="StepsText"/>
+          <p:cNvSpPr/>
+          <p:nvPr/>
+        </p:nvSpPr>
+        <p:spPr>
+          <a:xfrm>
+            <a:off x="475488" y="1572768"/>
+            <a:ext cx="6766560" cy="3291840"/>
           </a:xfrm>
           <a:prstGeom prst="rect">
             <a:avLst/>
@@ -2463,289 +2755,222 @@
           <a:ln/>
         </p:spPr>
         <p:txBody>
-          <a:bodyPr wrap="square" lIns="0" tIns="0" rIns="0" bIns="0" rtlCol="0" anchor="ctr"/>
-          <a:lstStyle/>
-          <a:p>
-            <a:pPr algn="l" indent="0" marL="0">
-              <a:buNone/>
-            </a:pPr>
-            <a:r>
-              <a:rPr lang="en-US" sz="4200" b="1" spc="400" kern="0" dirty="0">
-                <a:solidFill>
-                  <a:srgbClr val="FFFFFF"/>
-                </a:solidFill>
-                <a:latin typeface="Calibri" pitchFamily="34" charset="0"/>
-                <a:ea typeface="Calibri" pitchFamily="34" charset="-122"/>
-                <a:cs typeface="Calibri" pitchFamily="34" charset="-120"/>
-              </a:rPr>
-              <a:t>NEXT STEPS</a:t>
-            </a:r>
-            <a:endParaRPr lang="en-US" sz="4200" dirty="0"/>
-          </a:p>
-        </p:txBody>
-      </p:sp>
-      <p:sp>
-        <p:nvSpPr>
-          <p:cNvPr id="5" name="Shape 2"/>
-          <p:cNvSpPr/>
-          <p:nvPr/>
-        </p:nvSpPr>
-        <p:spPr>
-          <a:xfrm>
-            <a:off x="502920" y="1234440"/>
-            <a:ext cx="2011680" cy="0"/>
-          </a:xfrm>
-          <a:prstGeom prst="line">
-            <a:avLst/>
-          </a:prstGeom>
-          <a:noFill/>
-          <a:ln w="19050">
-            <a:solidFill>
-              <a:srgbClr val="4A7C59"/>
-            </a:solidFill>
-            <a:prstDash val="solid"/>
-          </a:ln>
-        </p:spPr>
-      </p:sp>
-      <p:sp>
-        <p:nvSpPr>
-          <p:cNvPr id="6" name="Text 3"/>
-          <p:cNvSpPr/>
-          <p:nvPr/>
-        </p:nvSpPr>
-        <p:spPr>
-          <a:xfrm>
-            <a:off x="502920" y="1417320"/>
-            <a:ext cx="6400800" cy="3429000"/>
-          </a:xfrm>
-          <a:prstGeom prst="rect">
-            <a:avLst/>
-          </a:prstGeom>
-          <a:noFill/>
-          <a:ln/>
-        </p:spPr>
-        <p:txBody>
           <a:bodyPr wrap="square" lIns="0" tIns="0" rIns="0" bIns="0" rtlCol="0" anchor="t"/>
           <a:lstStyle/>
           <a:p>
-            <a:pPr algn="l" indent="0" marL="0">
+            <a:pPr marL="0" indent="0" algn="l">
               <a:spcAft>
-                <a:spcPts val="400"/>
+                <a:spcPts val="500"/>
               </a:spcAft>
               <a:buNone/>
             </a:pPr>
             <a:r>
               <a:rPr lang="en-US" sz="1250" b="1" dirty="0">
                 <a:solidFill>
-                  <a:srgbClr val="9DC08B"/>
+                  <a:srgbClr val="C8910A"/>
                 </a:solidFill>
-                <a:latin typeface="Calibri" pitchFamily="34" charset="0"/>
-                <a:ea typeface="Calibri" pitchFamily="34" charset="-122"/>
-                <a:cs typeface="Calibri" pitchFamily="34" charset="-120"/>
+                <a:latin typeface="Century Gothic" pitchFamily="34" charset="0"/>
+                <a:ea typeface="Century Gothic" pitchFamily="34" charset="-122"/>
+                <a:cs typeface="Century Gothic" pitchFamily="34" charset="-120"/>
               </a:rPr>
-              <a:t>1.   </a:t>
+              <a:t>1.  </a:t>
             </a:r>
-            <a:pPr algn="l" indent="0" marL="0">
-              <a:spcAft>
-                <a:spcPts val="400"/>
-              </a:spcAft>
-              <a:buNone/>
-            </a:pPr>
             <a:r>
               <a:rPr lang="en-US" sz="1250" dirty="0">
                 <a:solidFill>
-                  <a:srgbClr val="C5D5BB"/>
+                  <a:srgbClr val="AAAAAA"/>
                 </a:solidFill>
-                <a:latin typeface="Calibri" pitchFamily="34" charset="0"/>
-                <a:ea typeface="Calibri" pitchFamily="34" charset="-122"/>
-                <a:cs typeface="Calibri" pitchFamily="34" charset="-120"/>
+                <a:latin typeface="IBM Plex Sans" pitchFamily="34" charset="0"/>
+                <a:ea typeface="IBM Plex Sans" pitchFamily="34" charset="-122"/>
+                <a:cs typeface="IBM Plex Sans" pitchFamily="34" charset="-120"/>
               </a:rPr>
-              <a:t>Review concepts and share reactions — what's working, what isn't</a:t>
+              <a:t xml:space="preserve">May 8   -   Logo finalized</a:t>
             </a:r>
             <a:endParaRPr lang="en-US" sz="1250" dirty="0"/>
           </a:p>
           <a:p>
-            <a:pPr algn="l" indent="0" marL="0">
+            <a:pPr marL="0" indent="0" algn="l">
               <a:spcAft>
-                <a:spcPts val="400"/>
+                <a:spcPts val="500"/>
               </a:spcAft>
               <a:buNone/>
             </a:pPr>
             <a:r>
               <a:rPr lang="en-US" sz="1250" b="1" dirty="0">
                 <a:solidFill>
-                  <a:srgbClr val="9DC08B"/>
+                  <a:srgbClr val="C8910A"/>
                 </a:solidFill>
-                <a:latin typeface="Calibri" pitchFamily="34" charset="0"/>
-                <a:ea typeface="Calibri" pitchFamily="34" charset="-122"/>
-                <a:cs typeface="Calibri" pitchFamily="34" charset="-120"/>
+                <a:latin typeface="Century Gothic" pitchFamily="34" charset="0"/>
+                <a:ea typeface="Century Gothic" pitchFamily="34" charset="-122"/>
+                <a:cs typeface="Century Gothic" pitchFamily="34" charset="-120"/>
               </a:rPr>
-              <a:t>2.   </a:t>
+              <a:t>2.  </a:t>
             </a:r>
-            <a:pPr algn="l" indent="0" marL="0">
-              <a:spcAft>
-                <a:spcPts val="400"/>
-              </a:spcAft>
-              <a:buNone/>
-            </a:pPr>
             <a:r>
               <a:rPr lang="en-US" sz="1250" dirty="0">
                 <a:solidFill>
-                  <a:srgbClr val="C5D5BB"/>
+                  <a:srgbClr val="AAAAAA"/>
                 </a:solidFill>
-                <a:latin typeface="Calibri" pitchFamily="34" charset="0"/>
-                <a:ea typeface="Calibri" pitchFamily="34" charset="-122"/>
-                <a:cs typeface="Calibri" pitchFamily="34" charset="-120"/>
+                <a:latin typeface="IBM Plex Sans" pitchFamily="34" charset="0"/>
+                <a:ea typeface="IBM Plex Sans" pitchFamily="34" charset="-122"/>
+                <a:cs typeface="IBM Plex Sans" pitchFamily="34" charset="-120"/>
               </a:rPr>
-              <a:t>Mark calls direction — one concept moves forward  (target: May 7)</a:t>
+              <a:t xml:space="preserve">May 12  -   Style guide and brand standards</a:t>
             </a:r>
             <a:endParaRPr lang="en-US" sz="1250" dirty="0"/>
           </a:p>
           <a:p>
-            <a:pPr algn="l" indent="0" marL="0">
+            <a:pPr marL="0" indent="0" algn="l">
               <a:spcAft>
-                <a:spcPts val="400"/>
+                <a:spcPts val="500"/>
               </a:spcAft>
               <a:buNone/>
             </a:pPr>
             <a:r>
               <a:rPr lang="en-US" sz="1250" b="1" dirty="0">
                 <a:solidFill>
-                  <a:srgbClr val="9DC08B"/>
+                  <a:srgbClr val="C8910A"/>
                 </a:solidFill>
-                <a:latin typeface="Calibri" pitchFamily="34" charset="0"/>
-                <a:ea typeface="Calibri" pitchFamily="34" charset="-122"/>
-                <a:cs typeface="Calibri" pitchFamily="34" charset="-120"/>
+                <a:latin typeface="Century Gothic" pitchFamily="34" charset="0"/>
+                <a:ea typeface="Century Gothic" pitchFamily="34" charset="-122"/>
+                <a:cs typeface="Century Gothic" pitchFamily="34" charset="-120"/>
               </a:rPr>
-              <a:t>3.   </a:t>
+              <a:t>3.  </a:t>
             </a:r>
-            <a:pPr algn="l" indent="0" marL="0">
-              <a:spcAft>
-                <a:spcPts val="400"/>
-              </a:spcAft>
-              <a:buNone/>
-            </a:pPr>
             <a:r>
               <a:rPr lang="en-US" sz="1250" dirty="0">
                 <a:solidFill>
-                  <a:srgbClr val="C5D5BB"/>
+                  <a:srgbClr val="AAAAAA"/>
                 </a:solidFill>
-                <a:latin typeface="Calibri" pitchFamily="34" charset="0"/>
-                <a:ea typeface="Calibri" pitchFamily="34" charset="-122"/>
-                <a:cs typeface="Calibri" pitchFamily="34" charset="-120"/>
+                <a:latin typeface="IBM Plex Sans" pitchFamily="34" charset="0"/>
+                <a:ea typeface="IBM Plex Sans" pitchFamily="34" charset="-122"/>
+                <a:cs typeface="IBM Plex Sans" pitchFamily="34" charset="-120"/>
               </a:rPr>
-              <a:t>Michael refines selected concept to final logo  (target: May 9)</a:t>
+              <a:t xml:space="preserve">May 14  -   Poster visual system and swag design begins</a:t>
             </a:r>
             <a:endParaRPr lang="en-US" sz="1250" dirty="0"/>
           </a:p>
           <a:p>
-            <a:pPr algn="l" indent="0" marL="0">
+            <a:pPr marL="0" indent="0" algn="l">
               <a:spcAft>
-                <a:spcPts val="400"/>
+                <a:spcPts val="500"/>
               </a:spcAft>
               <a:buNone/>
             </a:pPr>
             <a:r>
               <a:rPr lang="en-US" sz="1250" b="1" dirty="0">
                 <a:solidFill>
-                  <a:srgbClr val="9DC08B"/>
+                  <a:srgbClr val="C8910A"/>
                 </a:solidFill>
-                <a:latin typeface="Calibri" pitchFamily="34" charset="0"/>
-                <a:ea typeface="Calibri" pitchFamily="34" charset="-122"/>
-                <a:cs typeface="Calibri" pitchFamily="34" charset="-120"/>
+                <a:latin typeface="Century Gothic" pitchFamily="34" charset="0"/>
+                <a:ea typeface="Century Gothic" pitchFamily="34" charset="-122"/>
+                <a:cs typeface="Century Gothic" pitchFamily="34" charset="-120"/>
               </a:rPr>
-              <a:t>4.   </a:t>
+              <a:t>4.  </a:t>
             </a:r>
-            <a:pPr algn="l" indent="0" marL="0">
-              <a:spcAft>
-                <a:spcPts val="400"/>
-              </a:spcAft>
-              <a:buNone/>
-            </a:pPr>
             <a:r>
               <a:rPr lang="en-US" sz="1250" dirty="0">
                 <a:solidFill>
-                  <a:srgbClr val="C5D5BB"/>
+                  <a:srgbClr val="AAAAAA"/>
                 </a:solidFill>
-                <a:latin typeface="Calibri" pitchFamily="34" charset="0"/>
-                <a:ea typeface="Calibri" pitchFamily="34" charset="-122"/>
-                <a:cs typeface="Calibri" pitchFamily="34" charset="-120"/>
+                <a:latin typeface="IBM Plex Sans" pitchFamily="34" charset="0"/>
+                <a:ea typeface="IBM Plex Sans" pitchFamily="34" charset="-122"/>
+                <a:cs typeface="IBM Plex Sans" pitchFamily="34" charset="-120"/>
               </a:rPr>
-              <a:t>Final logo delivered in all formats: SVG, PNG (light + dark), EPS</a:t>
+              <a:t xml:space="preserve">May 15  -   Logo animation loop</a:t>
             </a:r>
             <a:endParaRPr lang="en-US" sz="1250" dirty="0"/>
           </a:p>
           <a:p>
-            <a:pPr algn="l" indent="0" marL="0">
+            <a:pPr marL="0" indent="0" algn="l">
               <a:spcAft>
-                <a:spcPts val="400"/>
+                <a:spcPts val="500"/>
               </a:spcAft>
               <a:buNone/>
             </a:pPr>
             <a:r>
               <a:rPr lang="en-US" sz="1250" b="1" dirty="0">
                 <a:solidFill>
-                  <a:srgbClr val="9DC08B"/>
+                  <a:srgbClr val="C8910A"/>
                 </a:solidFill>
-                <a:latin typeface="Calibri" pitchFamily="34" charset="0"/>
-                <a:ea typeface="Calibri" pitchFamily="34" charset="-122"/>
-                <a:cs typeface="Calibri" pitchFamily="34" charset="-120"/>
+                <a:latin typeface="Century Gothic" pitchFamily="34" charset="0"/>
+                <a:ea typeface="Century Gothic" pitchFamily="34" charset="-122"/>
+                <a:cs typeface="Century Gothic" pitchFamily="34" charset="-120"/>
               </a:rPr>
-              <a:t>5.   </a:t>
+              <a:t>5.  </a:t>
             </a:r>
-            <a:pPr algn="l" indent="0" marL="0">
-              <a:spcAft>
-                <a:spcPts val="400"/>
-              </a:spcAft>
-              <a:buNone/>
-            </a:pPr>
             <a:r>
               <a:rPr lang="en-US" sz="1250" dirty="0">
                 <a:solidFill>
-                  <a:srgbClr val="C5D5BB"/>
+                  <a:srgbClr val="AAAAAA"/>
                 </a:solidFill>
-                <a:latin typeface="Calibri" pitchFamily="34" charset="0"/>
-                <a:ea typeface="Calibri" pitchFamily="34" charset="-122"/>
-                <a:cs typeface="Calibri" pitchFamily="34" charset="-120"/>
+                <a:latin typeface="IBM Plex Sans" pitchFamily="34" charset="0"/>
+                <a:ea typeface="IBM Plex Sans" pitchFamily="34" charset="-122"/>
+                <a:cs typeface="IBM Plex Sans" pitchFamily="34" charset="-120"/>
               </a:rPr>
-              <a:t>Brand guidelines follow same day — color, type, usage rules</a:t>
+              <a:t xml:space="preserve">May 19  -   PPT template</a:t>
             </a:r>
             <a:endParaRPr lang="en-US" sz="1250" dirty="0"/>
           </a:p>
           <a:p>
-            <a:pPr algn="l" indent="0" marL="0">
+            <a:pPr marL="0" indent="0" algn="l">
               <a:spcAft>
-                <a:spcPts val="400"/>
+                <a:spcPts val="500"/>
               </a:spcAft>
               <a:buNone/>
             </a:pPr>
             <a:r>
               <a:rPr lang="en-US" sz="1250" b="1" dirty="0">
                 <a:solidFill>
-                  <a:srgbClr val="9DC08B"/>
+                  <a:srgbClr val="C8910A"/>
                 </a:solidFill>
-                <a:latin typeface="Calibri" pitchFamily="34" charset="0"/>
-                <a:ea typeface="Calibri" pitchFamily="34" charset="-122"/>
-                <a:cs typeface="Calibri" pitchFamily="34" charset="-120"/>
+                <a:latin typeface="Century Gothic" pitchFamily="34" charset="0"/>
+                <a:ea typeface="Century Gothic" pitchFamily="34" charset="-122"/>
+                <a:cs typeface="Century Gothic" pitchFamily="34" charset="-120"/>
               </a:rPr>
-              <a:t>6.   </a:t>
+              <a:t>6.  </a:t>
             </a:r>
-            <a:pPr algn="l" indent="0" marL="0">
+            <a:r>
+              <a:rPr lang="en-US" sz="1250" dirty="0">
+                <a:solidFill>
+                  <a:srgbClr val="AAAAAA"/>
+                </a:solidFill>
+                <a:latin typeface="IBM Plex Sans" pitchFamily="34" charset="0"/>
+                <a:ea typeface="IBM Plex Sans" pitchFamily="34" charset="-122"/>
+                <a:cs typeface="IBM Plex Sans" pitchFamily="34" charset="-120"/>
+              </a:rPr>
+              <a:t xml:space="preserve">May 22  -   Ambassador and Executive poster review</a:t>
+            </a:r>
+            <a:endParaRPr lang="en-US" sz="1250" dirty="0"/>
+          </a:p>
+          <a:p>
+            <a:pPr marL="0" indent="0" algn="l">
               <a:spcAft>
-                <a:spcPts val="400"/>
+                <a:spcPts val="500"/>
               </a:spcAft>
               <a:buNone/>
             </a:pPr>
             <a:r>
+              <a:rPr lang="en-US" sz="1250" b="1" dirty="0">
+                <a:solidFill>
+                  <a:srgbClr val="C8910A"/>
+                </a:solidFill>
+                <a:latin typeface="Century Gothic" pitchFamily="34" charset="0"/>
+                <a:ea typeface="Century Gothic" pitchFamily="34" charset="-122"/>
+                <a:cs typeface="Century Gothic" pitchFamily="34" charset="-120"/>
+              </a:rPr>
+              <a:t>7.  </a:t>
+            </a:r>
+            <a:r>
               <a:rPr lang="en-US" sz="1250" dirty="0">
                 <a:solidFill>
-                  <a:srgbClr val="C5D5BB"/>
+                  <a:srgbClr val="AAAAAA"/>
                 </a:solidFill>
-                <a:latin typeface="Calibri" pitchFamily="34" charset="0"/>
-                <a:ea typeface="Calibri" pitchFamily="34" charset="-122"/>
-                <a:cs typeface="Calibri" pitchFamily="34" charset="-120"/>
+                <a:latin typeface="IBM Plex Sans" pitchFamily="34" charset="0"/>
+                <a:ea typeface="IBM Plex Sans" pitchFamily="34" charset="-122"/>
+                <a:cs typeface="IBM Plex Sans" pitchFamily="34" charset="-120"/>
               </a:rPr>
-              <a:t>Lee and Camille begin visual systems (posters, badges, swag, PPT template) off approved logo</a:t>
+              <a:t xml:space="preserve">May 26  -   Printed materials to vendor</a:t>
             </a:r>
             <a:endParaRPr lang="en-US" sz="1250" dirty="0"/>
           </a:p>
@@ -3052,4 +3277,319 @@
     </a:ext>
   </a:extLst>
 </a:theme>
+</file>
+
+<file path=ppt/theme/theme2.xml><?xml version="1.0" encoding="utf-8"?>
+<a:theme xmlns:a="http://schemas.openxmlformats.org/drawingml/2006/main" name="Office Theme">
+  <a:themeElements>
+    <a:clrScheme name="Office">
+      <a:dk1>
+        <a:sysClr val="windowText" lastClr="000000"/>
+      </a:dk1>
+      <a:lt1>
+        <a:sysClr val="window" lastClr="FFFFFF"/>
+      </a:lt1>
+      <a:dk2>
+        <a:srgbClr val="0E2841"/>
+      </a:dk2>
+      <a:lt2>
+        <a:srgbClr val="E8E8E8"/>
+      </a:lt2>
+      <a:accent1>
+        <a:srgbClr val="156082"/>
+      </a:accent1>
+      <a:accent2>
+        <a:srgbClr val="E97132"/>
+      </a:accent2>
+      <a:accent3>
+        <a:srgbClr val="196B24"/>
+      </a:accent3>
+      <a:accent4>
+        <a:srgbClr val="0F9ED5"/>
+      </a:accent4>
+      <a:accent5>
+        <a:srgbClr val="A02B93"/>
+      </a:accent5>
+      <a:accent6>
+        <a:srgbClr val="4EA72E"/>
+      </a:accent6>
+      <a:hlink>
+        <a:srgbClr val="467886"/>
+      </a:hlink>
+      <a:folHlink>
+        <a:srgbClr val="96607D"/>
+      </a:folHlink>
+    </a:clrScheme>
+    <a:fontScheme name="Office">
+      <a:majorFont>
+        <a:latin typeface="Aptos Display" panose="02110004020202020204"/>
+        <a:ea typeface=""/>
+        <a:cs typeface=""/>
+        <a:font script="Jpan" typeface="游ゴシック Light"/>
+        <a:font script="Hang" typeface="맑은 고딕"/>
+        <a:font script="Hans" typeface="等线 Light"/>
+        <a:font script="Hant" typeface="新細明體"/>
+        <a:font script="Arab" typeface="Times New Roman"/>
+        <a:font script="Hebr" typeface="Times New Roman"/>
+        <a:font script="Thai" typeface="Angsana New"/>
+        <a:font script="Ethi" typeface="Nyala"/>
+        <a:font script="Beng" typeface="Vrinda"/>
+        <a:font script="Gujr" typeface="Shruti"/>
+        <a:font script="Khmr" typeface="MoolBoran"/>
+        <a:font script="Knda" typeface="Tunga"/>
+        <a:font script="Guru" typeface="Raavi"/>
+        <a:font script="Cans" typeface="Euphemia"/>
+        <a:font script="Cher" typeface="Plantagenet Cherokee"/>
+        <a:font script="Yiii" typeface="Microsoft Yi Baiti"/>
+        <a:font script="Tibt" typeface="Microsoft Himalaya"/>
+        <a:font script="Thaa" typeface="MV Boli"/>
+        <a:font script="Deva" typeface="Mangal"/>
+        <a:font script="Telu" typeface="Gautami"/>
+        <a:font script="Taml" typeface="Latha"/>
+        <a:font script="Syrc" typeface="Estrangelo Edessa"/>
+        <a:font script="Orya" typeface="Kalinga"/>
+        <a:font script="Mlym" typeface="Kartika"/>
+        <a:font script="Laoo" typeface="DokChampa"/>
+        <a:font script="Sinh" typeface="Iskoola Pota"/>
+        <a:font script="Mong" typeface="Mongolian Baiti"/>
+        <a:font script="Viet" typeface="Times New Roman"/>
+        <a:font script="Uigh" typeface="Microsoft Uighur"/>
+        <a:font script="Geor" typeface="Sylfaen"/>
+        <a:font script="Armn" typeface="Arial"/>
+        <a:font script="Bugi" typeface="Leelawadee UI"/>
+        <a:font script="Bopo" typeface="Microsoft JhengHei"/>
+        <a:font script="Java" typeface="Javanese Text"/>
+        <a:font script="Lisu" typeface="Segoe UI"/>
+        <a:font script="Mymr" typeface="Myanmar Text"/>
+        <a:font script="Nkoo" typeface="Ebrima"/>
+        <a:font script="Olck" typeface="Nirmala UI"/>
+        <a:font script="Osma" typeface="Ebrima"/>
+        <a:font script="Phag" typeface="Phagspa"/>
+        <a:font script="Syrn" typeface="Estrangelo Edessa"/>
+        <a:font script="Syrj" typeface="Estrangelo Edessa"/>
+        <a:font script="Syre" typeface="Estrangelo Edessa"/>
+        <a:font script="Sora" typeface="Nirmala UI"/>
+        <a:font script="Tale" typeface="Microsoft Tai Le"/>
+        <a:font script="Talu" typeface="Microsoft New Tai Lue"/>
+        <a:font script="Tfng" typeface="Ebrima"/>
+      </a:majorFont>
+      <a:minorFont>
+        <a:latin typeface="Aptos" panose="02110004020202020204"/>
+        <a:ea typeface=""/>
+        <a:cs typeface=""/>
+        <a:font script="Jpan" typeface="游ゴシック"/>
+        <a:font script="Hang" typeface="맑은 고딕"/>
+        <a:font script="Hans" typeface="等线"/>
+        <a:font script="Hant" typeface="新細明體"/>
+        <a:font script="Arab" typeface="Arial"/>
+        <a:font script="Hebr" typeface="Arial"/>
+        <a:font script="Thai" typeface="Cordia New"/>
+        <a:font script="Ethi" typeface="Nyala"/>
+        <a:font script="Beng" typeface="Vrinda"/>
+        <a:font script="Gujr" typeface="Shruti"/>
+        <a:font script="Khmr" typeface="DaunPenh"/>
+        <a:font script="Knda" typeface="Tunga"/>
+        <a:font script="Guru" typeface="Raavi"/>
+        <a:font script="Cans" typeface="Euphemia"/>
+        <a:font script="Cher" typeface="Plantagenet Cherokee"/>
+        <a:font script="Yiii" typeface="Microsoft Yi Baiti"/>
+        <a:font script="Tibt" typeface="Microsoft Himalaya"/>
+        <a:font script="Thaa" typeface="MV Boli"/>
+        <a:font script="Deva" typeface="Mangal"/>
+        <a:font script="Telu" typeface="Gautami"/>
+        <a:font script="Taml" typeface="Latha"/>
+        <a:font script="Syrc" typeface="Estrangelo Edessa"/>
+        <a:font script="Orya" typeface="Kalinga"/>
+        <a:font script="Mlym" typeface="Kartika"/>
+        <a:font script="Laoo" typeface="DokChampa"/>
+        <a:font script="Sinh" typeface="Iskoola Pota"/>
+        <a:font script="Mong" typeface="Mongolian Baiti"/>
+        <a:font script="Viet" typeface="Arial"/>
+        <a:font script="Uigh" typeface="Microsoft Uighur"/>
+        <a:font script="Geor" typeface="Sylfaen"/>
+        <a:font script="Armn" typeface="Arial"/>
+        <a:font script="Bugi" typeface="Leelawadee UI"/>
+        <a:font script="Bopo" typeface="Microsoft JhengHei"/>
+        <a:font script="Java" typeface="Javanese Text"/>
+        <a:font script="Lisu" typeface="Segoe UI"/>
+        <a:font script="Mymr" typeface="Myanmar Text"/>
+        <a:font script="Nkoo" typeface="Ebrima"/>
+        <a:font script="Olck" typeface="Nirmala UI"/>
+        <a:font script="Osma" typeface="Ebrima"/>
+        <a:font script="Phag" typeface="Phagspa"/>
+        <a:font script="Syrn" typeface="Estrangelo Edessa"/>
+        <a:font script="Syrj" typeface="Estrangelo Edessa"/>
+        <a:font script="Syre" typeface="Estrangelo Edessa"/>
+        <a:font script="Sora" typeface="Nirmala UI"/>
+        <a:font script="Tale" typeface="Microsoft Tai Le"/>
+        <a:font script="Talu" typeface="Microsoft New Tai Lue"/>
+        <a:font script="Tfng" typeface="Ebrima"/>
+      </a:minorFont>
+    </a:fontScheme>
+    <a:fmtScheme name="Office">
+      <a:fillStyleLst>
+        <a:solidFill>
+          <a:schemeClr val="phClr"/>
+        </a:solidFill>
+        <a:gradFill rotWithShape="1">
+          <a:gsLst>
+            <a:gs pos="0">
+              <a:schemeClr val="phClr">
+                <a:lumMod val="110000"/>
+                <a:satMod val="105000"/>
+                <a:tint val="67000"/>
+              </a:schemeClr>
+            </a:gs>
+            <a:gs pos="50000">
+              <a:schemeClr val="phClr">
+                <a:lumMod val="105000"/>
+                <a:satMod val="103000"/>
+                <a:tint val="73000"/>
+              </a:schemeClr>
+            </a:gs>
+            <a:gs pos="100000">
+              <a:schemeClr val="phClr">
+                <a:lumMod val="105000"/>
+                <a:satMod val="109000"/>
+                <a:tint val="81000"/>
+              </a:schemeClr>
+            </a:gs>
+          </a:gsLst>
+          <a:lin ang="5400000" scaled="0"/>
+        </a:gradFill>
+        <a:gradFill rotWithShape="1">
+          <a:gsLst>
+            <a:gs pos="0">
+              <a:schemeClr val="phClr">
+                <a:satMod val="103000"/>
+                <a:lumMod val="102000"/>
+                <a:tint val="94000"/>
+              </a:schemeClr>
+            </a:gs>
+            <a:gs pos="50000">
+              <a:schemeClr val="phClr">
+                <a:satMod val="110000"/>
+                <a:lumMod val="100000"/>
+                <a:shade val="100000"/>
+              </a:schemeClr>
+            </a:gs>
+            <a:gs pos="100000">
+              <a:schemeClr val="phClr">
+                <a:lumMod val="99000"/>
+                <a:satMod val="120000"/>
+                <a:shade val="78000"/>
+              </a:schemeClr>
+            </a:gs>
+          </a:gsLst>
+          <a:lin ang="5400000" scaled="0"/>
+        </a:gradFill>
+      </a:fillStyleLst>
+      <a:lnStyleLst>
+        <a:ln w="12700" cap="flat" cmpd="sng" algn="ctr">
+          <a:solidFill>
+            <a:schemeClr val="phClr"/>
+          </a:solidFill>
+          <a:prstDash val="solid"/>
+          <a:miter lim="800000"/>
+        </a:ln>
+        <a:ln w="19050" cap="flat" cmpd="sng" algn="ctr">
+          <a:solidFill>
+            <a:schemeClr val="phClr"/>
+          </a:solidFill>
+          <a:prstDash val="solid"/>
+          <a:miter lim="800000"/>
+        </a:ln>
+        <a:ln w="25400" cap="flat" cmpd="sng" algn="ctr">
+          <a:solidFill>
+            <a:schemeClr val="phClr"/>
+          </a:solidFill>
+          <a:prstDash val="solid"/>
+          <a:miter lim="800000"/>
+        </a:ln>
+      </a:lnStyleLst>
+      <a:effectStyleLst>
+        <a:effectStyle>
+          <a:effectLst/>
+        </a:effectStyle>
+        <a:effectStyle>
+          <a:effectLst/>
+        </a:effectStyle>
+        <a:effectStyle>
+          <a:effectLst>
+            <a:outerShdw blurRad="57150" dist="19050" dir="5400000" algn="ctr" rotWithShape="0">
+              <a:srgbClr val="000000">
+                <a:alpha val="63000"/>
+              </a:srgbClr>
+            </a:outerShdw>
+          </a:effectLst>
+        </a:effectStyle>
+      </a:effectStyleLst>
+      <a:bgFillStyleLst>
+        <a:solidFill>
+          <a:schemeClr val="phClr"/>
+        </a:solidFill>
+        <a:solidFill>
+          <a:schemeClr val="phClr">
+            <a:tint val="95000"/>
+            <a:satMod val="170000"/>
+          </a:schemeClr>
+        </a:solidFill>
+        <a:gradFill rotWithShape="1">
+          <a:gsLst>
+            <a:gs pos="0">
+              <a:schemeClr val="phClr">
+                <a:tint val="93000"/>
+                <a:satMod val="150000"/>
+                <a:shade val="98000"/>
+                <a:lumMod val="102000"/>
+              </a:schemeClr>
+            </a:gs>
+            <a:gs pos="50000">
+              <a:schemeClr val="phClr">
+                <a:tint val="98000"/>
+                <a:satMod val="130000"/>
+                <a:shade val="90000"/>
+                <a:lumMod val="103000"/>
+              </a:schemeClr>
+            </a:gs>
+            <a:gs pos="100000">
+              <a:schemeClr val="phClr">
+                <a:shade val="63000"/>
+                <a:satMod val="120000"/>
+              </a:schemeClr>
+            </a:gs>
+          </a:gsLst>
+          <a:lin ang="5400000" scaled="0"/>
+        </a:gradFill>
+      </a:bgFillStyleLst>
+    </a:fmtScheme>
+  </a:themeElements>
+  <a:objectDefaults>
+    <a:lnDef>
+      <a:spPr/>
+      <a:bodyPr/>
+      <a:lstStyle/>
+      <a:style>
+        <a:lnRef idx="2">
+          <a:schemeClr val="accent1"/>
+        </a:lnRef>
+        <a:fillRef idx="0">
+          <a:schemeClr val="accent1"/>
+        </a:fillRef>
+        <a:effectRef idx="1">
+          <a:schemeClr val="accent1"/>
+        </a:effectRef>
+        <a:fontRef idx="minor">
+          <a:schemeClr val="tx1"/>
+        </a:fontRef>
+      </a:style>
+    </a:lnDef>
+  </a:objectDefaults>
+  <a:extraClrSchemeLst/>
+  <a:extLst>
+    <a:ext uri="{05A4C25C-085E-4340-85A3-A5531E510DB2}">
+      <thm15:themeFamily xmlns:thm15="http://schemas.microsoft.com/office/thememl/2012/main" name="Office Theme" id="{2E142A2C-CD16-42D6-873A-C26D2A0506FA}" vid="{1BDDFF52-6CD6-40A5-AB3C-68EB2F1E4D0A}"/>
+    </a:ext>
+  </a:extLst>
+</a:theme>
 </file>
</xml_diff>